<commit_message>
Added meeting 4 slides
</commit_message>
<xml_diff>
--- a/Classifying Metabolic Fluxes.pptx
+++ b/Classifying Metabolic Fluxes.pptx
@@ -2,51 +2,55 @@
 <file path=ppt/presentation.xml><?xml version="1.0" encoding="utf-8"?>
 <p:presentation xmlns:a="http://schemas.openxmlformats.org/drawingml/2006/main" xmlns:r="http://schemas.openxmlformats.org/officeDocument/2006/relationships" xmlns:p="http://schemas.openxmlformats.org/presentationml/2006/main" strictFirstAndLastChars="0" saveSubsetFonts="1">
   <p:sldMasterIdLst>
-    <p:sldMasterId id="2147483662" r:id="rId18"/>
+    <p:sldMasterId id="2147483662" r:id="rId22"/>
   </p:sldMasterIdLst>
   <p:notesMasterIdLst>
-    <p:notesMasterId r:id="rId50"/>
+    <p:notesMasterId r:id="rId58"/>
   </p:notesMasterIdLst>
   <p:handoutMasterIdLst>
-    <p:handoutMasterId r:id="rId51"/>
+    <p:handoutMasterId r:id="rId59"/>
   </p:handoutMasterIdLst>
   <p:sldIdLst>
-    <p:sldId id="271" r:id="rId19"/>
-    <p:sldId id="263" r:id="rId20"/>
-    <p:sldId id="264" r:id="rId21"/>
-    <p:sldId id="266" r:id="rId22"/>
-    <p:sldId id="262" r:id="rId23"/>
-    <p:sldId id="260" r:id="rId24"/>
-    <p:sldId id="270" r:id="rId25"/>
-    <p:sldId id="272" r:id="rId26"/>
-    <p:sldId id="273" r:id="rId27"/>
-    <p:sldId id="274" r:id="rId28"/>
-    <p:sldId id="275" r:id="rId29"/>
-    <p:sldId id="267" r:id="rId30"/>
-    <p:sldId id="276" r:id="rId31"/>
-    <p:sldId id="277" r:id="rId32"/>
-    <p:sldId id="280" r:id="rId33"/>
-    <p:sldId id="285" r:id="rId34"/>
-    <p:sldId id="283" r:id="rId35"/>
-    <p:sldId id="282" r:id="rId36"/>
-    <p:sldId id="286" r:id="rId37"/>
-    <p:sldId id="287" r:id="rId38"/>
-    <p:sldId id="288" r:id="rId39"/>
-    <p:sldId id="289" r:id="rId40"/>
-    <p:sldId id="290" r:id="rId41"/>
-    <p:sldId id="256" r:id="rId42"/>
-    <p:sldId id="268" r:id="rId43"/>
-    <p:sldId id="257" r:id="rId44"/>
-    <p:sldId id="261" r:id="rId45"/>
-    <p:sldId id="265" r:id="rId46"/>
-    <p:sldId id="269" r:id="rId47"/>
-    <p:sldId id="278" r:id="rId48"/>
-    <p:sldId id="279" r:id="rId49"/>
+    <p:sldId id="271" r:id="rId23"/>
+    <p:sldId id="263" r:id="rId24"/>
+    <p:sldId id="264" r:id="rId25"/>
+    <p:sldId id="266" r:id="rId26"/>
+    <p:sldId id="262" r:id="rId27"/>
+    <p:sldId id="260" r:id="rId28"/>
+    <p:sldId id="270" r:id="rId29"/>
+    <p:sldId id="272" r:id="rId30"/>
+    <p:sldId id="273" r:id="rId31"/>
+    <p:sldId id="274" r:id="rId32"/>
+    <p:sldId id="275" r:id="rId33"/>
+    <p:sldId id="267" r:id="rId34"/>
+    <p:sldId id="276" r:id="rId35"/>
+    <p:sldId id="277" r:id="rId36"/>
+    <p:sldId id="280" r:id="rId37"/>
+    <p:sldId id="285" r:id="rId38"/>
+    <p:sldId id="283" r:id="rId39"/>
+    <p:sldId id="282" r:id="rId40"/>
+    <p:sldId id="286" r:id="rId41"/>
+    <p:sldId id="287" r:id="rId42"/>
+    <p:sldId id="288" r:id="rId43"/>
+    <p:sldId id="291" r:id="rId44"/>
+    <p:sldId id="293" r:id="rId45"/>
+    <p:sldId id="294" r:id="rId46"/>
+    <p:sldId id="256" r:id="rId47"/>
+    <p:sldId id="268" r:id="rId48"/>
+    <p:sldId id="257" r:id="rId49"/>
+    <p:sldId id="261" r:id="rId50"/>
+    <p:sldId id="265" r:id="rId51"/>
+    <p:sldId id="269" r:id="rId52"/>
+    <p:sldId id="278" r:id="rId53"/>
+    <p:sldId id="279" r:id="rId54"/>
+    <p:sldId id="289" r:id="rId55"/>
+    <p:sldId id="290" r:id="rId56"/>
+    <p:sldId id="295" r:id="rId57"/>
   </p:sldIdLst>
   <p:sldSz cx="12190413" cy="6858000"/>
   <p:notesSz cx="6858000" cy="9144000"/>
   <p:custDataLst>
-    <p:tags r:id="rId52"/>
+    <p:tags r:id="rId60"/>
   </p:custDataLst>
   <p:defaultTextStyle>
     <a:defPPr>
@@ -1179,7 +1183,7 @@
             <a:fld id="{C734BB09-483B-4C4B-A5A4-C02A22055B01}" type="slidenum">
               <a:rPr lang="da-DK" smtClean="0"/>
               <a:pPr/>
-              <a:t>24</a:t>
+              <a:t>25</a:t>
             </a:fld>
             <a:endParaRPr lang="da-DK" dirty="0"/>
           </a:p>
@@ -11858,10 +11862,10 @@
       </p:grpSpPr>
       <p:sp>
         <p:nvSpPr>
-          <p:cNvPr id="2" name="Title 1">
+          <p:cNvPr id="4" name="Title 3">
             <a:extLst>
               <a:ext uri="{FF2B5EF4-FFF2-40B4-BE49-F238E27FC236}">
-                <a16:creationId xmlns:a16="http://schemas.microsoft.com/office/drawing/2014/main" id="{F0F072BA-15AB-A06E-F068-5D97E092B912}"/>
+                <a16:creationId xmlns:a16="http://schemas.microsoft.com/office/drawing/2014/main" id="{674358EA-4D5B-461F-997D-DE6729900DE7}"/>
               </a:ext>
             </a:extLst>
           </p:cNvPr>
@@ -11869,7 +11873,7 @@
             <a:spLocks noGrp="1"/>
           </p:cNvSpPr>
           <p:nvPr>
-            <p:ph type="title"/>
+            <p:ph type="ctrTitle"/>
           </p:nvPr>
         </p:nvSpPr>
         <p:spPr/>
@@ -11877,16 +11881,27 @@
           <a:bodyPr/>
           <a:lstStyle/>
           <a:p>
-            <a:endParaRPr lang="da-DK" dirty="0"/>
-          </a:p>
-        </p:txBody>
-      </p:sp>
-      <p:sp>
-        <p:nvSpPr>
-          <p:cNvPr id="3" name="Content Placeholder 2">
+            <a:r>
+              <a:rPr lang="en-GB" sz="4400" dirty="0"/>
+              <a:t>Dimensionality Reduction on </a:t>
+            </a:r>
+            <a:r>
+              <a:rPr lang="en-GB" sz="4400" dirty="0" err="1"/>
+              <a:t>dFBA</a:t>
+            </a:r>
+            <a:r>
+              <a:rPr lang="en-GB" sz="4400" dirty="0"/>
+              <a:t> </a:t>
+            </a:r>
+          </a:p>
+        </p:txBody>
+      </p:sp>
+      <p:sp>
+        <p:nvSpPr>
+          <p:cNvPr id="5" name="Subtitle 4">
             <a:extLst>
               <a:ext uri="{FF2B5EF4-FFF2-40B4-BE49-F238E27FC236}">
-                <a16:creationId xmlns:a16="http://schemas.microsoft.com/office/drawing/2014/main" id="{4BE04EF9-98E8-A355-BBEC-4448F145A8E6}"/>
+                <a16:creationId xmlns:a16="http://schemas.microsoft.com/office/drawing/2014/main" id="{88CE6942-A17C-4247-86C6-41FACF7E90AC}"/>
               </a:ext>
             </a:extLst>
           </p:cNvPr>
@@ -11894,7 +11909,7 @@
             <a:spLocks noGrp="1"/>
           </p:cNvSpPr>
           <p:nvPr>
-            <p:ph idx="1"/>
+            <p:ph type="subTitle" idx="1"/>
           </p:nvPr>
         </p:nvSpPr>
         <p:spPr/>
@@ -11903,29 +11918,18 @@
           <a:lstStyle/>
           <a:p>
             <a:r>
-              <a:rPr lang="en-US" b="0" i="0" dirty="0">
-                <a:solidFill>
-                  <a:srgbClr val="374151"/>
-                </a:solidFill>
-                <a:effectLst/>
-                <a:latin typeface="+mj-lt"/>
-              </a:rPr>
-              <a:t>Predictive Modeling: Autoencoders can be extended to include additional layers beyond the decoder. By incorporating supervised learning techniques, such as adding classification or regression layers on top of the autoencoder architecture, the learned features can be used for predictive modeling tasks. The encoder captures meaningful representations of the cell lifeline data, which can aid in predicting specific outcomes or properties of interest.</a:t>
-            </a:r>
-          </a:p>
-          <a:p>
-            <a:endParaRPr lang="da-DK" dirty="0">
-              <a:latin typeface="+mj-lt"/>
-            </a:endParaRPr>
-          </a:p>
-        </p:txBody>
-      </p:sp>
-      <p:sp>
-        <p:nvSpPr>
-          <p:cNvPr id="4" name="Slide Number Placeholder 3">
+              <a:rPr lang="en-GB" dirty="0"/>
+              <a:t>Meeting 4 – July 10, 2023</a:t>
+            </a:r>
+          </a:p>
+        </p:txBody>
+      </p:sp>
+      <p:sp>
+        <p:nvSpPr>
+          <p:cNvPr id="3" name="Slide Number Placeholder 2">
             <a:extLst>
               <a:ext uri="{FF2B5EF4-FFF2-40B4-BE49-F238E27FC236}">
-                <a16:creationId xmlns:a16="http://schemas.microsoft.com/office/drawing/2014/main" id="{3CAA5A6A-B9FE-C8EE-6D27-1E49CEC1E775}"/>
+                <a16:creationId xmlns:a16="http://schemas.microsoft.com/office/drawing/2014/main" id="{0AA221E4-1851-497D-90EE-984C7112166A}"/>
               </a:ext>
             </a:extLst>
           </p:cNvPr>
@@ -11933,7 +11937,7 @@
             <a:spLocks noGrp="1"/>
           </p:cNvSpPr>
           <p:nvPr>
-            <p:ph type="sldNum" sz="quarter" idx="11"/>
+            <p:ph type="sldNum" sz="quarter" idx="17"/>
           </p:nvPr>
         </p:nvSpPr>
         <p:spPr/>
@@ -11941,7 +11945,7 @@
           <a:bodyPr/>
           <a:lstStyle/>
           <a:p>
-            <a:fld id="{103EA872-A674-449B-A120-B97244F8E91D}" type="slidenum">
+            <a:fld id="{24C8C45C-947F-4981-8B3F-4F32E973C901}" type="slidenum">
               <a:rPr lang="en-GB" smtClean="0"/>
               <a:pPr/>
               <a:t>22</a:t>
@@ -11951,9 +11955,13 @@
         </p:txBody>
       </p:sp>
     </p:spTree>
+    <p:custDataLst>
+      <p:custData r:id="rId1"/>
+      <p:custData r:id="rId2"/>
+    </p:custDataLst>
     <p:extLst>
       <p:ext uri="{BB962C8B-B14F-4D97-AF65-F5344CB8AC3E}">
-        <p14:creationId xmlns:p14="http://schemas.microsoft.com/office/powerpoint/2010/main" val="2982816725"/>
+        <p14:creationId xmlns:p14="http://schemas.microsoft.com/office/powerpoint/2010/main" val="1200527365"/>
       </p:ext>
     </p:extLst>
   </p:cSld>
@@ -11985,7 +11993,7 @@
           <p:cNvPr id="2" name="Title 1">
             <a:extLst>
               <a:ext uri="{FF2B5EF4-FFF2-40B4-BE49-F238E27FC236}">
-                <a16:creationId xmlns:a16="http://schemas.microsoft.com/office/drawing/2014/main" id="{24B1D29F-BE75-C5DB-B74E-AF092621385C}"/>
+                <a16:creationId xmlns:a16="http://schemas.microsoft.com/office/drawing/2014/main" id="{A53C08FB-0846-DDA6-B07A-5D1BECD3A1BE}"/>
               </a:ext>
             </a:extLst>
           </p:cNvPr>
@@ -12003,7 +12011,7 @@
           <a:p>
             <a:r>
               <a:rPr lang="en-US" dirty="0"/>
-              <a:t>Autoencoders &amp; Metabolic Networks</a:t>
+              <a:t>Update</a:t>
             </a:r>
             <a:endParaRPr lang="da-DK" dirty="0"/>
           </a:p>
@@ -12014,7 +12022,7 @@
           <p:cNvPr id="3" name="Content Placeholder 2">
             <a:extLst>
               <a:ext uri="{FF2B5EF4-FFF2-40B4-BE49-F238E27FC236}">
-                <a16:creationId xmlns:a16="http://schemas.microsoft.com/office/drawing/2014/main" id="{EA318381-9B42-27F0-E957-EBAC624824BF}"/>
+                <a16:creationId xmlns:a16="http://schemas.microsoft.com/office/drawing/2014/main" id="{EF2C1B03-E041-86B0-950D-82FF37F6ACF2}"/>
               </a:ext>
             </a:extLst>
           </p:cNvPr>
@@ -12030,115 +12038,90 @@
           <a:bodyPr/>
           <a:lstStyle/>
           <a:p>
-            <a:pPr algn="l"/>
-            <a:r>
-              <a:rPr lang="en-US" sz="1100" b="0" i="0" dirty="0">
-                <a:solidFill>
-                  <a:srgbClr val="374151"/>
-                </a:solidFill>
-                <a:effectLst/>
-                <a:latin typeface="+mj-lt"/>
-              </a:rPr>
-              <a:t>Autoencoders can provide valuable insights into cell lifelines and metabolic networks by learning compact and meaningful representations of the underlying data. Here are some ways in which autoencoders can help us gain information about cell lifelines and metabolic networks:</a:t>
-            </a:r>
-          </a:p>
-          <a:p>
-            <a:pPr algn="l">
-              <a:buFont typeface="+mj-lt"/>
-              <a:buAutoNum type="arabicPeriod"/>
-            </a:pPr>
-            <a:r>
-              <a:rPr lang="en-US" sz="1100" b="0" i="0" dirty="0">
-                <a:solidFill>
-                  <a:srgbClr val="374151"/>
-                </a:solidFill>
-                <a:effectLst/>
-                <a:latin typeface="+mj-lt"/>
-              </a:rPr>
-              <a:t>Reconstruction of Cell Lifelines: Autoencoders are trained to reconstruct their input data from compressed latent representations. By training an autoencoder on cell lifeline data, the decoder part of the autoencoder can generate reconstructed lifelines that closely resemble the original input. Comparing the reconstructed lifelines with the original ones can help identify patterns, similarities, and differences. This can provide insights into the dynamics and variations within the lifelines and help uncover underlying regulatory mechanisms.</a:t>
-            </a:r>
-          </a:p>
-          <a:p>
-            <a:pPr algn="l">
-              <a:buFont typeface="+mj-lt"/>
-              <a:buAutoNum type="arabicPeriod"/>
-            </a:pPr>
-            <a:r>
-              <a:rPr lang="en-US" sz="1100" b="0" i="0" dirty="0">
-                <a:solidFill>
-                  <a:srgbClr val="374151"/>
-                </a:solidFill>
-                <a:effectLst/>
-                <a:latin typeface="+mj-lt"/>
-              </a:rPr>
-              <a:t>Feature Extraction: The encoder part of an autoencoder learns to extract the most salient features from the input data. In the context of cell lifelines, this can include identifying important metabolites, proteins, or gene expressions that contribute significantly to the observed variations. By analyzing the learned latent space, we can gain insights into the most informative features and their relationships, which can aid in understanding the underlying biology and metabolic processes.</a:t>
-            </a:r>
-          </a:p>
-          <a:p>
-            <a:pPr algn="l">
-              <a:buFont typeface="+mj-lt"/>
-              <a:buAutoNum type="arabicPeriod"/>
-            </a:pPr>
-            <a:r>
-              <a:rPr lang="en-US" sz="1100" b="0" i="0" dirty="0">
-                <a:solidFill>
-                  <a:srgbClr val="374151"/>
-                </a:solidFill>
-                <a:effectLst/>
-                <a:latin typeface="+mj-lt"/>
-              </a:rPr>
-              <a:t>Anomaly Detection: Autoencoders can be used to detect anomalies or deviations from normal cell lifelines. By training an autoencoder on a dataset of healthy or normal lifelines, it can learn to reconstruct normal patterns. When presented with anomalous lifelines, the autoencoder will have higher reconstruction errors, indicating a deviation from the normal behavior. This can help identify aberrations in metabolic networks or cell lifelines, which may indicate disease conditions, drug responses, or other important phenomena.</a:t>
-            </a:r>
-          </a:p>
-          <a:p>
-            <a:pPr algn="l">
-              <a:buFont typeface="+mj-lt"/>
-              <a:buAutoNum type="arabicPeriod"/>
-            </a:pPr>
-            <a:r>
-              <a:rPr lang="en-US" sz="1100" b="0" i="0" dirty="0">
-                <a:solidFill>
-                  <a:srgbClr val="374151"/>
-                </a:solidFill>
-                <a:effectLst/>
-                <a:latin typeface="+mj-lt"/>
-              </a:rPr>
-              <a:t>Pathway Reconstruction: Autoencoders can capture the hierarchical relationships and interactions within metabolic networks. By training an autoencoder on metabolic pathway data, it can learn to reconstruct the pathways and identify the key reactions and metabolites involved. This can provide insights into the functional relationships between reactions, the flow of metabolites, and the overall structure of the metabolic network.</a:t>
-            </a:r>
-          </a:p>
-          <a:p>
-            <a:pPr algn="l">
-              <a:buFont typeface="+mj-lt"/>
-              <a:buAutoNum type="arabicPeriod"/>
-            </a:pPr>
-            <a:r>
-              <a:rPr lang="en-US" sz="1100" b="0" i="0" dirty="0">
-                <a:solidFill>
-                  <a:srgbClr val="374151"/>
-                </a:solidFill>
-                <a:effectLst/>
-                <a:latin typeface="+mj-lt"/>
-              </a:rPr>
-              <a:t>Discovery of Novel Enzymatic Reactions: Autoencoders can be used to predict potential enzymatic reactions and uncover novel interactions within metabolic networks. By training an autoencoder on a comprehensive set of known enzymatic reactions, it can learn the underlying patterns and relationships. The decoder part of the autoencoder can then generate predictions of new enzymatic reactions based on the learned representations. These predictions can guide experimental investigations and contribute to the expansion and refinement of existing metabolic networks.</a:t>
-            </a:r>
-          </a:p>
-          <a:p>
-            <a:pPr algn="l"/>
-            <a:r>
-              <a:rPr lang="en-US" sz="1100" b="0" i="0" dirty="0">
-                <a:solidFill>
-                  <a:srgbClr val="374151"/>
-                </a:solidFill>
-                <a:effectLst/>
-                <a:latin typeface="+mj-lt"/>
-              </a:rPr>
-              <a:t>In summary, autoencoders offer valuable tools for analyzing cell lifelines and metabolic networks by extracting meaningful features, reconstructing patterns, detecting anomalies, and facilitating the discovery of novel interactions and reactions. These insights can advance our understanding of biological systems, disease mechanisms, and potential drug targets.</a:t>
-            </a:r>
-          </a:p>
-          <a:p>
-            <a:endParaRPr lang="da-DK" sz="1100" dirty="0">
-              <a:latin typeface="+mj-lt"/>
-            </a:endParaRPr>
+            <a:r>
+              <a:rPr lang="en-US" dirty="0"/>
+              <a:t>Updated with 3D matrix (3754 x 15 x 95) with 15 cell lifelines (ran on personal computer) </a:t>
+            </a:r>
+          </a:p>
+          <a:p>
+            <a:r>
+              <a:rPr lang="en-US" dirty="0"/>
+              <a:t>Working</a:t>
+            </a:r>
+          </a:p>
+          <a:p>
+            <a:pPr lvl="1"/>
+            <a:r>
+              <a:rPr lang="en-US" dirty="0"/>
+              <a:t>Add layers but memory problems</a:t>
+            </a:r>
+          </a:p>
+          <a:p>
+            <a:pPr lvl="1"/>
+            <a:r>
+              <a:rPr lang="en-US" dirty="0"/>
+              <a:t>Increasing training epochs and trials</a:t>
+            </a:r>
+          </a:p>
+          <a:p>
+            <a:pPr lvl="1"/>
+            <a:r>
+              <a:rPr lang="en-US" dirty="0"/>
+              <a:t>Adjust hyperparameter search space </a:t>
+            </a:r>
+          </a:p>
+          <a:p>
+            <a:pPr lvl="1"/>
+            <a:r>
+              <a:rPr lang="en-US" dirty="0"/>
+              <a:t>Run for more lifelines </a:t>
+            </a:r>
+          </a:p>
+          <a:p>
+            <a:pPr lvl="1"/>
+            <a:r>
+              <a:rPr lang="en-US" dirty="0"/>
+              <a:t>Latent space representation </a:t>
+            </a:r>
+          </a:p>
+          <a:p>
+            <a:pPr lvl="1"/>
+            <a:r>
+              <a:rPr lang="en-US" dirty="0"/>
+              <a:t>Time steps can skip </a:t>
+            </a:r>
+          </a:p>
+          <a:p>
+            <a:pPr lvl="1"/>
+            <a:r>
+              <a:rPr lang="en-US" dirty="0"/>
+              <a:t>LSTM </a:t>
+            </a:r>
+          </a:p>
+          <a:p>
+            <a:pPr lvl="1"/>
+            <a:r>
+              <a:rPr lang="en-US" dirty="0"/>
+              <a:t>Goal – reduce number of reaction fluxes</a:t>
+            </a:r>
+          </a:p>
+          <a:p>
+            <a:pPr lvl="1"/>
+            <a:r>
+              <a:rPr lang="en-US" dirty="0"/>
+              <a:t>Improve this latent space </a:t>
+            </a:r>
+          </a:p>
+          <a:p>
+            <a:pPr lvl="1"/>
+            <a:r>
+              <a:rPr lang="en-US" dirty="0"/>
+              <a:t>Try biomass reaction</a:t>
+            </a:r>
+          </a:p>
+          <a:p>
+            <a:pPr lvl="1"/>
+            <a:endParaRPr lang="en-US" dirty="0"/>
           </a:p>
         </p:txBody>
       </p:sp>
@@ -12147,7 +12130,7 @@
           <p:cNvPr id="4" name="Slide Number Placeholder 3">
             <a:extLst>
               <a:ext uri="{FF2B5EF4-FFF2-40B4-BE49-F238E27FC236}">
-                <a16:creationId xmlns:a16="http://schemas.microsoft.com/office/drawing/2014/main" id="{FB397322-7415-8304-26DF-8B8987B56633}"/>
+                <a16:creationId xmlns:a16="http://schemas.microsoft.com/office/drawing/2014/main" id="{7598AC90-03D6-112D-452A-AF392584D89C}"/>
               </a:ext>
             </a:extLst>
           </p:cNvPr>
@@ -12175,7 +12158,7 @@
     </p:spTree>
     <p:extLst>
       <p:ext uri="{BB962C8B-B14F-4D97-AF65-F5344CB8AC3E}">
-        <p14:creationId xmlns:p14="http://schemas.microsoft.com/office/powerpoint/2010/main" val="3285401051"/>
+        <p14:creationId xmlns:p14="http://schemas.microsoft.com/office/powerpoint/2010/main" val="2773807427"/>
       </p:ext>
     </p:extLst>
   </p:cSld>
@@ -12204,10 +12187,10 @@
       </p:grpSpPr>
       <p:sp>
         <p:nvSpPr>
-          <p:cNvPr id="3" name="Slide Number Placeholder 2">
+          <p:cNvPr id="5" name="Title 4">
             <a:extLst>
               <a:ext uri="{FF2B5EF4-FFF2-40B4-BE49-F238E27FC236}">
-                <a16:creationId xmlns:a16="http://schemas.microsoft.com/office/drawing/2014/main" id="{0013EF6E-BC23-40A0-80D4-1EBE64DCC5D9}"/>
+                <a16:creationId xmlns:a16="http://schemas.microsoft.com/office/drawing/2014/main" id="{43AB9D89-4678-4B3C-8679-3E429EFBB2DD}"/>
               </a:ext>
             </a:extLst>
           </p:cNvPr>
@@ -12215,7 +12198,58 @@
             <a:spLocks noGrp="1"/>
           </p:cNvSpPr>
           <p:nvPr>
-            <p:ph type="sldNum" sz="quarter" idx="12"/>
+            <p:ph type="title"/>
+          </p:nvPr>
+        </p:nvSpPr>
+        <p:spPr/>
+        <p:txBody>
+          <a:bodyPr/>
+          <a:lstStyle/>
+          <a:p>
+            <a:r>
+              <a:rPr lang="en-GB" dirty="0"/>
+              <a:t>Example Results</a:t>
+            </a:r>
+          </a:p>
+        </p:txBody>
+      </p:sp>
+      <p:pic>
+        <p:nvPicPr>
+          <p:cNvPr id="3" name="Content Placeholder 2">
+            <a:extLst>
+              <a:ext uri="{FF2B5EF4-FFF2-40B4-BE49-F238E27FC236}">
+                <a16:creationId xmlns:a16="http://schemas.microsoft.com/office/drawing/2014/main" id="{7FE91E6A-D45B-39B0-0FE1-899250E0368F}"/>
+              </a:ext>
+            </a:extLst>
+          </p:cNvPr>
+          <p:cNvPicPr>
+            <a:picLocks noGrp="1" noChangeAspect="1"/>
+          </p:cNvPicPr>
+          <p:nvPr>
+            <p:ph idx="1"/>
+          </p:nvPr>
+        </p:nvPicPr>
+        <p:blipFill>
+          <a:blip r:embed="rId4"/>
+          <a:stretch>
+            <a:fillRect/>
+          </a:stretch>
+        </p:blipFill>
+        <p:spPr>
+          <a:xfrm>
+            <a:off x="4799806" y="1676400"/>
+            <a:ext cx="5400675" cy="4333875"/>
+          </a:xfrm>
+        </p:spPr>
+      </p:pic>
+      <p:sp>
+        <p:nvSpPr>
+          <p:cNvPr id="4" name="Slide Number Placeholder 3"/>
+          <p:cNvSpPr>
+            <a:spLocks noGrp="1"/>
+          </p:cNvSpPr>
+          <p:nvPr>
+            <p:ph type="sldNum" sz="quarter" idx="11"/>
           </p:nvPr>
         </p:nvSpPr>
         <p:spPr/>
@@ -12232,11 +12266,153 @@
           </a:p>
         </p:txBody>
       </p:sp>
+      <p:sp>
+        <p:nvSpPr>
+          <p:cNvPr id="8" name="TextBox 7">
+            <a:extLst>
+              <a:ext uri="{FF2B5EF4-FFF2-40B4-BE49-F238E27FC236}">
+                <a16:creationId xmlns:a16="http://schemas.microsoft.com/office/drawing/2014/main" id="{543DC015-5F8C-7614-5C5F-1814E0267DD3}"/>
+              </a:ext>
+            </a:extLst>
+          </p:cNvPr>
+          <p:cNvSpPr txBox="1"/>
+          <p:nvPr/>
+        </p:nvSpPr>
+        <p:spPr>
+          <a:xfrm>
+            <a:off x="1774726" y="2151727"/>
+            <a:ext cx="2438400" cy="2554545"/>
+          </a:xfrm>
+          <a:prstGeom prst="rect">
+            <a:avLst/>
+          </a:prstGeom>
+          <a:noFill/>
+        </p:spPr>
+        <p:txBody>
+          <a:bodyPr wrap="square">
+            <a:spAutoFit/>
+          </a:bodyPr>
+          <a:lstStyle/>
+          <a:p>
+            <a:r>
+              <a:rPr lang="da-DK" b="0" i="0" dirty="0">
+                <a:effectLst/>
+                <a:latin typeface="Consolas" panose="020B0609020204030204" pitchFamily="49" charset="0"/>
+              </a:rPr>
+              <a:t>Best </a:t>
+            </a:r>
+            <a:r>
+              <a:rPr lang="da-DK" b="0" i="0" dirty="0" err="1">
+                <a:effectLst/>
+                <a:latin typeface="Consolas" panose="020B0609020204030204" pitchFamily="49" charset="0"/>
+              </a:rPr>
+              <a:t>Hyperparameters</a:t>
+            </a:r>
+            <a:r>
+              <a:rPr lang="da-DK" b="0" i="0" dirty="0">
+                <a:effectLst/>
+                <a:latin typeface="Consolas" panose="020B0609020204030204" pitchFamily="49" charset="0"/>
+              </a:rPr>
+              <a:t>: {'</a:t>
+            </a:r>
+            <a:r>
+              <a:rPr lang="da-DK" b="0" i="0" dirty="0" err="1">
+                <a:effectLst/>
+                <a:latin typeface="Consolas" panose="020B0609020204030204" pitchFamily="49" charset="0"/>
+              </a:rPr>
+              <a:t>hidden_units</a:t>
+            </a:r>
+            <a:r>
+              <a:rPr lang="da-DK" b="0" i="0" dirty="0">
+                <a:effectLst/>
+                <a:latin typeface="Consolas" panose="020B0609020204030204" pitchFamily="49" charset="0"/>
+              </a:rPr>
+              <a:t>': 17, '</a:t>
+            </a:r>
+            <a:r>
+              <a:rPr lang="da-DK" b="0" i="0" dirty="0" err="1">
+                <a:effectLst/>
+                <a:latin typeface="Consolas" panose="020B0609020204030204" pitchFamily="49" charset="0"/>
+              </a:rPr>
+              <a:t>latent_units</a:t>
+            </a:r>
+            <a:r>
+              <a:rPr lang="da-DK" b="0" i="0" dirty="0">
+                <a:effectLst/>
+                <a:latin typeface="Consolas" panose="020B0609020204030204" pitchFamily="49" charset="0"/>
+              </a:rPr>
+              <a:t>': 34, '</a:t>
+            </a:r>
+            <a:r>
+              <a:rPr lang="da-DK" b="0" i="0" dirty="0" err="1">
+                <a:effectLst/>
+                <a:latin typeface="Consolas" panose="020B0609020204030204" pitchFamily="49" charset="0"/>
+              </a:rPr>
+              <a:t>activation</a:t>
+            </a:r>
+            <a:r>
+              <a:rPr lang="da-DK" b="0" i="0" dirty="0">
+                <a:effectLst/>
+                <a:latin typeface="Consolas" panose="020B0609020204030204" pitchFamily="49" charset="0"/>
+              </a:rPr>
+              <a:t>': '</a:t>
+            </a:r>
+            <a:r>
+              <a:rPr lang="da-DK" b="0" i="0" dirty="0" err="1">
+                <a:effectLst/>
+                <a:latin typeface="Consolas" panose="020B0609020204030204" pitchFamily="49" charset="0"/>
+              </a:rPr>
+              <a:t>relu</a:t>
+            </a:r>
+            <a:r>
+              <a:rPr lang="da-DK" b="0" i="0" dirty="0">
+                <a:effectLst/>
+                <a:latin typeface="Consolas" panose="020B0609020204030204" pitchFamily="49" charset="0"/>
+              </a:rPr>
+              <a:t>', '</a:t>
+            </a:r>
+            <a:r>
+              <a:rPr lang="da-DK" b="0" i="0" dirty="0" err="1">
+                <a:effectLst/>
+                <a:latin typeface="Consolas" panose="020B0609020204030204" pitchFamily="49" charset="0"/>
+              </a:rPr>
+              <a:t>learning_rate</a:t>
+            </a:r>
+            <a:r>
+              <a:rPr lang="da-DK" b="0" i="0" dirty="0">
+                <a:effectLst/>
+                <a:latin typeface="Consolas" panose="020B0609020204030204" pitchFamily="49" charset="0"/>
+              </a:rPr>
+              <a:t>': 0.000506829711966478} Best </a:t>
+            </a:r>
+            <a:r>
+              <a:rPr lang="da-DK" b="0" i="0" dirty="0" err="1">
+                <a:effectLst/>
+                <a:latin typeface="Consolas" panose="020B0609020204030204" pitchFamily="49" charset="0"/>
+              </a:rPr>
+              <a:t>Loss</a:t>
+            </a:r>
+            <a:r>
+              <a:rPr lang="da-DK" b="0" i="0" dirty="0">
+                <a:effectLst/>
+                <a:latin typeface="Consolas" panose="020B0609020204030204" pitchFamily="49" charset="0"/>
+              </a:rPr>
+              <a:t>: 1.9310521729525925</a:t>
+            </a:r>
+            <a:endParaRPr lang="da-DK" dirty="0"/>
+          </a:p>
+        </p:txBody>
+      </p:sp>
     </p:spTree>
     <p:custDataLst>
       <p:custData r:id="rId1"/>
       <p:custData r:id="rId2"/>
     </p:custDataLst>
+    <p:extLst>
+      <p:ext uri="{BB962C8B-B14F-4D97-AF65-F5344CB8AC3E}">
+        <p14:creationId xmlns:p14="http://schemas.microsoft.com/office/powerpoint/2010/main" val="2529553098"/>
+      </p:ext>
+    </p:extLst>
   </p:cSld>
   <p:clrMapOvr>
     <a:masterClrMapping/>
@@ -12263,10 +12439,10 @@
       </p:grpSpPr>
       <p:sp>
         <p:nvSpPr>
-          <p:cNvPr id="2" name="Title 1">
+          <p:cNvPr id="3" name="Slide Number Placeholder 2">
             <a:extLst>
               <a:ext uri="{FF2B5EF4-FFF2-40B4-BE49-F238E27FC236}">
-                <a16:creationId xmlns:a16="http://schemas.microsoft.com/office/drawing/2014/main" id="{2D762CC8-4CC0-9138-5473-7FC27E5D7A53}"/>
+                <a16:creationId xmlns:a16="http://schemas.microsoft.com/office/drawing/2014/main" id="{0013EF6E-BC23-40A0-80D4-1EBE64DCC5D9}"/>
               </a:ext>
             </a:extLst>
           </p:cNvPr>
@@ -12274,91 +12450,7 @@
             <a:spLocks noGrp="1"/>
           </p:cNvSpPr>
           <p:nvPr>
-            <p:ph type="title"/>
-          </p:nvPr>
-        </p:nvSpPr>
-        <p:spPr/>
-        <p:txBody>
-          <a:bodyPr/>
-          <a:lstStyle/>
-          <a:p>
-            <a:endParaRPr lang="da-DK" dirty="0"/>
-          </a:p>
-        </p:txBody>
-      </p:sp>
-      <p:sp>
-        <p:nvSpPr>
-          <p:cNvPr id="3" name="Content Placeholder 2">
-            <a:extLst>
-              <a:ext uri="{FF2B5EF4-FFF2-40B4-BE49-F238E27FC236}">
-                <a16:creationId xmlns:a16="http://schemas.microsoft.com/office/drawing/2014/main" id="{47705C7C-0F20-86C6-1EDE-0F7CB872484A}"/>
-              </a:ext>
-            </a:extLst>
-          </p:cNvPr>
-          <p:cNvSpPr>
-            <a:spLocks noGrp="1"/>
-          </p:cNvSpPr>
-          <p:nvPr>
-            <p:ph idx="1"/>
-          </p:nvPr>
-        </p:nvSpPr>
-        <p:spPr/>
-        <p:txBody>
-          <a:bodyPr/>
-          <a:lstStyle/>
-          <a:p>
-            <a:r>
-              <a:rPr lang="en-US" dirty="0"/>
-              <a:t>Feature Selection</a:t>
-            </a:r>
-          </a:p>
-          <a:p>
-            <a:r>
-              <a:rPr lang="en-US" dirty="0"/>
-              <a:t>Dimension reduction using PCA (large-scale PCA) </a:t>
-            </a:r>
-          </a:p>
-          <a:p>
-            <a:r>
-              <a:rPr lang="en-US" dirty="0"/>
-              <a:t>Explained variance, and scree plot</a:t>
-            </a:r>
-          </a:p>
-          <a:p>
-            <a:r>
-              <a:rPr lang="en-US" dirty="0"/>
-              <a:t>Loadings and Biplot</a:t>
-            </a:r>
-          </a:p>
-          <a:p>
-            <a:r>
-              <a:rPr lang="en-US" dirty="0"/>
-              <a:t>Extracting the most informative features</a:t>
-            </a:r>
-          </a:p>
-          <a:p>
-            <a:r>
-              <a:rPr lang="en-US" dirty="0"/>
-              <a:t>Outlier detection</a:t>
-            </a:r>
-            <a:endParaRPr lang="da-DK" dirty="0"/>
-          </a:p>
-        </p:txBody>
-      </p:sp>
-      <p:sp>
-        <p:nvSpPr>
-          <p:cNvPr id="4" name="Slide Number Placeholder 3">
-            <a:extLst>
-              <a:ext uri="{FF2B5EF4-FFF2-40B4-BE49-F238E27FC236}">
-                <a16:creationId xmlns:a16="http://schemas.microsoft.com/office/drawing/2014/main" id="{642F6DD0-67CF-E9ED-A975-D6554E2C2270}"/>
-              </a:ext>
-            </a:extLst>
-          </p:cNvPr>
-          <p:cNvSpPr>
-            <a:spLocks noGrp="1"/>
-          </p:cNvSpPr>
-          <p:nvPr>
-            <p:ph type="sldNum" sz="quarter" idx="11"/>
+            <p:ph type="sldNum" sz="quarter" idx="12"/>
           </p:nvPr>
         </p:nvSpPr>
         <p:spPr/>
@@ -12376,11 +12468,10 @@
         </p:txBody>
       </p:sp>
     </p:spTree>
-    <p:extLst>
-      <p:ext uri="{BB962C8B-B14F-4D97-AF65-F5344CB8AC3E}">
-        <p14:creationId xmlns:p14="http://schemas.microsoft.com/office/powerpoint/2010/main" val="4121892305"/>
-      </p:ext>
-    </p:extLst>
+    <p:custDataLst>
+      <p:custData r:id="rId1"/>
+      <p:custData r:id="rId2"/>
+    </p:custDataLst>
   </p:cSld>
   <p:clrMapOvr>
     <a:masterClrMapping/>
@@ -12407,10 +12498,10 @@
       </p:grpSpPr>
       <p:sp>
         <p:nvSpPr>
-          <p:cNvPr id="5" name="Title 4">
+          <p:cNvPr id="2" name="Title 1">
             <a:extLst>
               <a:ext uri="{FF2B5EF4-FFF2-40B4-BE49-F238E27FC236}">
-                <a16:creationId xmlns:a16="http://schemas.microsoft.com/office/drawing/2014/main" id="{43AB9D89-4678-4B3C-8679-3E429EFBB2DD}"/>
+                <a16:creationId xmlns:a16="http://schemas.microsoft.com/office/drawing/2014/main" id="{2D762CC8-4CC0-9138-5473-7FC27E5D7A53}"/>
               </a:ext>
             </a:extLst>
           </p:cNvPr>
@@ -12426,20 +12517,16 @@
           <a:bodyPr/>
           <a:lstStyle/>
           <a:p>
-            <a:r>
-              <a:rPr lang="en-US" dirty="0"/>
-              <a:t>Dynamic simulations of microbial communities under perturbations: opportunities for microbiome engineering</a:t>
-            </a:r>
-            <a:endParaRPr lang="en-GB" dirty="0"/>
-          </a:p>
-        </p:txBody>
-      </p:sp>
-      <p:sp>
-        <p:nvSpPr>
-          <p:cNvPr id="6" name="Content Placeholder 5">
+            <a:endParaRPr lang="da-DK" dirty="0"/>
+          </a:p>
+        </p:txBody>
+      </p:sp>
+      <p:sp>
+        <p:nvSpPr>
+          <p:cNvPr id="3" name="Content Placeholder 2">
             <a:extLst>
               <a:ext uri="{FF2B5EF4-FFF2-40B4-BE49-F238E27FC236}">
-                <a16:creationId xmlns:a16="http://schemas.microsoft.com/office/drawing/2014/main" id="{5A5890CD-8F90-4FE7-841F-F7B0C2865BA2}"/>
+                <a16:creationId xmlns:a16="http://schemas.microsoft.com/office/drawing/2014/main" id="{47705C7C-0F20-86C6-1EDE-0F7CB872484A}"/>
               </a:ext>
             </a:extLst>
           </p:cNvPr>
@@ -12456,43 +12543,52 @@
           <a:lstStyle/>
           <a:p>
             <a:r>
-              <a:rPr lang="en-US" sz="1400" dirty="0"/>
-              <a:t>Data Preprocessing: Before clustering the fluxes, the researchers perform preprocessing steps to filter out irrelevant reactions. They select a subset of equidistant time points from the time-series data. Reactions with constant values over time are removed. They also eliminate transport and exchange reactions, focusing on reactions within the inner metabolism. Additionally, redundant reactions are removed, keeping only one representative for coupled reactions.</a:t>
-            </a:r>
-          </a:p>
-          <a:p>
-            <a:endParaRPr lang="en-US" sz="1400" dirty="0"/>
-          </a:p>
-          <a:p>
-            <a:r>
-              <a:rPr lang="en-US" sz="1400" dirty="0"/>
-              <a:t>Clustering: The metabolic reactions, based on their flux values over time and samples, are grouped using unsupervised machine learning techniques, specifically clustering algorithms. The paper refers to criteria from a previous study to determine the optimal number of clusters.</a:t>
-            </a:r>
-          </a:p>
-          <a:p>
-            <a:endParaRPr lang="en-US" sz="1400" dirty="0"/>
-          </a:p>
-          <a:p>
-            <a:r>
-              <a:rPr lang="en-US" sz="1400" dirty="0"/>
-              <a:t>Random Forest Classifier: The flux-states resulting from clustering are used as labels for a Random Forest classifier. Random forests are an ensemble learning method that consists of multiple decision trees. In this case, the classifier is trained to predict the flux-state labels based on the reactions. This allows the researchers to identify which reactions contribute the most to differentiating between the flux-states.</a:t>
-            </a:r>
-          </a:p>
-          <a:p>
-            <a:endParaRPr lang="en-US" sz="1400" dirty="0"/>
-          </a:p>
-          <a:p>
-            <a:r>
-              <a:rPr lang="en-US" sz="1400" dirty="0"/>
-              <a:t>Feature Importance: The feature importance of the reactions is computed using the Mean Decrease in Accuracy (MDA) metric. This metric measures the importance of each reaction in the random forest classifier for accurately predicting the flux-states. By analyzing the feature importance, the researchers can identify the reactions that have the most significant impact on distinguishing different flux-states.</a:t>
-            </a:r>
-            <a:endParaRPr lang="en-GB" sz="1400" dirty="0"/>
-          </a:p>
-        </p:txBody>
-      </p:sp>
-      <p:sp>
-        <p:nvSpPr>
-          <p:cNvPr id="4" name="Slide Number Placeholder 3"/>
+              <a:rPr lang="en-US" dirty="0"/>
+              <a:t>Feature Selection</a:t>
+            </a:r>
+          </a:p>
+          <a:p>
+            <a:r>
+              <a:rPr lang="en-US" dirty="0"/>
+              <a:t>Dimension reduction using PCA (large-scale PCA) </a:t>
+            </a:r>
+          </a:p>
+          <a:p>
+            <a:r>
+              <a:rPr lang="en-US" dirty="0"/>
+              <a:t>Explained variance, and scree plot</a:t>
+            </a:r>
+          </a:p>
+          <a:p>
+            <a:r>
+              <a:rPr lang="en-US" dirty="0"/>
+              <a:t>Loadings and Biplot</a:t>
+            </a:r>
+          </a:p>
+          <a:p>
+            <a:r>
+              <a:rPr lang="en-US" dirty="0"/>
+              <a:t>Extracting the most informative features</a:t>
+            </a:r>
+          </a:p>
+          <a:p>
+            <a:r>
+              <a:rPr lang="en-US" dirty="0"/>
+              <a:t>Outlier detection</a:t>
+            </a:r>
+            <a:endParaRPr lang="da-DK" dirty="0"/>
+          </a:p>
+        </p:txBody>
+      </p:sp>
+      <p:sp>
+        <p:nvSpPr>
+          <p:cNvPr id="4" name="Slide Number Placeholder 3">
+            <a:extLst>
+              <a:ext uri="{FF2B5EF4-FFF2-40B4-BE49-F238E27FC236}">
+                <a16:creationId xmlns:a16="http://schemas.microsoft.com/office/drawing/2014/main" id="{642F6DD0-67CF-E9ED-A975-D6554E2C2270}"/>
+              </a:ext>
+            </a:extLst>
+          </p:cNvPr>
           <p:cNvSpPr>
             <a:spLocks noGrp="1"/>
           </p:cNvSpPr>
@@ -12515,13 +12611,9 @@
         </p:txBody>
       </p:sp>
     </p:spTree>
-    <p:custDataLst>
-      <p:custData r:id="rId1"/>
-      <p:custData r:id="rId2"/>
-    </p:custDataLst>
     <p:extLst>
       <p:ext uri="{BB962C8B-B14F-4D97-AF65-F5344CB8AC3E}">
-        <p14:creationId xmlns:p14="http://schemas.microsoft.com/office/powerpoint/2010/main" val="1796381250"/>
+        <p14:creationId xmlns:p14="http://schemas.microsoft.com/office/powerpoint/2010/main" val="4121892305"/>
       </p:ext>
     </p:extLst>
   </p:cSld>
@@ -12550,10 +12642,10 @@
       </p:grpSpPr>
       <p:sp>
         <p:nvSpPr>
-          <p:cNvPr id="2" name="Title 1">
+          <p:cNvPr id="5" name="Title 4">
             <a:extLst>
               <a:ext uri="{FF2B5EF4-FFF2-40B4-BE49-F238E27FC236}">
-                <a16:creationId xmlns:a16="http://schemas.microsoft.com/office/drawing/2014/main" id="{E0511799-4BB3-AD89-4D20-999AB8C5DB2B}"/>
+                <a16:creationId xmlns:a16="http://schemas.microsoft.com/office/drawing/2014/main" id="{43AB9D89-4678-4B3C-8679-3E429EFBB2DD}"/>
               </a:ext>
             </a:extLst>
           </p:cNvPr>
@@ -12571,18 +12663,18 @@
           <a:p>
             <a:r>
               <a:rPr lang="en-US" dirty="0"/>
-              <a:t>Preserving interpretability while using PCA</a:t>
-            </a:r>
-            <a:endParaRPr lang="da-DK" dirty="0"/>
-          </a:p>
-        </p:txBody>
-      </p:sp>
-      <p:sp>
-        <p:nvSpPr>
-          <p:cNvPr id="3" name="Content Placeholder 2">
+              <a:t>Dynamic simulations of microbial communities under perturbations: opportunities for microbiome engineering</a:t>
+            </a:r>
+            <a:endParaRPr lang="en-GB" dirty="0"/>
+          </a:p>
+        </p:txBody>
+      </p:sp>
+      <p:sp>
+        <p:nvSpPr>
+          <p:cNvPr id="6" name="Content Placeholder 5">
             <a:extLst>
               <a:ext uri="{FF2B5EF4-FFF2-40B4-BE49-F238E27FC236}">
-                <a16:creationId xmlns:a16="http://schemas.microsoft.com/office/drawing/2014/main" id="{6DC21131-EE78-651C-06D6-F4C3A24C68C8}"/>
+                <a16:creationId xmlns:a16="http://schemas.microsoft.com/office/drawing/2014/main" id="{5A5890CD-8F90-4FE7-841F-F7B0C2865BA2}"/>
               </a:ext>
             </a:extLst>
           </p:cNvPr>
@@ -12599,49 +12691,43 @@
           <a:lstStyle/>
           <a:p>
             <a:r>
-              <a:rPr lang="en-US" sz="1200" dirty="0"/>
-              <a:t>Feature Selection: Instead of relying solely on PCA for dimensionality reduction, you can perform feature selection techniques specifically tailored for your task. These techniques aim to identify the most informative and relevant reactions for clustering and analysis. Some popular feature selection methods include mutual information, L1 regularization (Lasso), recursive feature elimination, or variance thresholding. By selecting a subset of important reactions, you can retain the interpretability of the original metabolic reactions without relying on a latent space representation.</a:t>
-            </a:r>
-          </a:p>
-          <a:p>
-            <a:endParaRPr lang="en-US" sz="1200" dirty="0"/>
-          </a:p>
-          <a:p>
-            <a:r>
-              <a:rPr lang="en-US" sz="1200" dirty="0"/>
-              <a:t>Interpretability-Aware Dimensionality Reduction: Explore alternative dimensionality reduction techniques that prioritize interpretability while reducing the feature space. For example, methods like Non-negative Matrix Factorization (NMF) or Sparse Principal Component Analysis (Sparse PCA) can provide reduced-dimensional representations while still allowing for interpretation in terms of the original metabolic reactions.</a:t>
-            </a:r>
-          </a:p>
-          <a:p>
-            <a:endParaRPr lang="en-US" sz="1200" dirty="0"/>
-          </a:p>
-          <a:p>
-            <a:r>
-              <a:rPr lang="en-US" sz="1200" dirty="0"/>
-              <a:t>Integration of PCA with Feature Importance: If PCA is used as a preliminary step, you can combine it with the analysis of feature importance obtained from the subsequent random forest classifier. After applying PCA, you can use the reduced-dimensional representation as input to the random forest classifier. The feature importance analysis can then be performed on the original metabolic reactions rather than the PCA-transformed features. This way, you can identify the important reactions in the context of the original representation while still benefiting from the dimensionality reduction provided by PCA.</a:t>
-            </a:r>
-          </a:p>
-          <a:p>
-            <a:endParaRPr lang="en-US" sz="1200" dirty="0"/>
-          </a:p>
-          <a:p>
-            <a:r>
-              <a:rPr lang="en-US" sz="1200" dirty="0"/>
-              <a:t>Domain Expertise and Biologically Driven Filtering: Consider incorporating domain expertise and biological knowledge to guide the preprocessing steps. For instance, you can apply additional filtering criteria based on known biochemical pathways, functional categories of reactions, or other relevant biological constraints. By leveraging domain expertise, you can refine the filtering process and focus on reactions that are biologically meaningful for your specific analysis.</a:t>
-            </a:r>
-            <a:endParaRPr lang="da-DK" sz="1200" dirty="0"/>
-          </a:p>
-        </p:txBody>
-      </p:sp>
-      <p:sp>
-        <p:nvSpPr>
-          <p:cNvPr id="4" name="Slide Number Placeholder 3">
-            <a:extLst>
-              <a:ext uri="{FF2B5EF4-FFF2-40B4-BE49-F238E27FC236}">
-                <a16:creationId xmlns:a16="http://schemas.microsoft.com/office/drawing/2014/main" id="{5B1668A1-BEBF-76F3-C92B-E0B6E5A9E46A}"/>
-              </a:ext>
-            </a:extLst>
-          </p:cNvPr>
+              <a:rPr lang="en-US" sz="1400" dirty="0"/>
+              <a:t>Data Preprocessing: Before clustering the fluxes, the researchers perform preprocessing steps to filter out irrelevant reactions. They select a subset of equidistant time points from the time-series data. Reactions with constant values over time are removed. They also eliminate transport and exchange reactions, focusing on reactions within the inner metabolism. Additionally, redundant reactions are removed, keeping only one representative for coupled reactions.</a:t>
+            </a:r>
+          </a:p>
+          <a:p>
+            <a:endParaRPr lang="en-US" sz="1400" dirty="0"/>
+          </a:p>
+          <a:p>
+            <a:r>
+              <a:rPr lang="en-US" sz="1400" dirty="0"/>
+              <a:t>Clustering: The metabolic reactions, based on their flux values over time and samples, are grouped using unsupervised machine learning techniques, specifically clustering algorithms. The paper refers to criteria from a previous study to determine the optimal number of clusters.</a:t>
+            </a:r>
+          </a:p>
+          <a:p>
+            <a:endParaRPr lang="en-US" sz="1400" dirty="0"/>
+          </a:p>
+          <a:p>
+            <a:r>
+              <a:rPr lang="en-US" sz="1400" dirty="0"/>
+              <a:t>Random Forest Classifier: The flux-states resulting from clustering are used as labels for a Random Forest classifier. Random forests are an ensemble learning method that consists of multiple decision trees. In this case, the classifier is trained to predict the flux-state labels based on the reactions. This allows the researchers to identify which reactions contribute the most to differentiating between the flux-states.</a:t>
+            </a:r>
+          </a:p>
+          <a:p>
+            <a:endParaRPr lang="en-US" sz="1400" dirty="0"/>
+          </a:p>
+          <a:p>
+            <a:r>
+              <a:rPr lang="en-US" sz="1400" dirty="0"/>
+              <a:t>Feature Importance: The feature importance of the reactions is computed using the Mean Decrease in Accuracy (MDA) metric. This metric measures the importance of each reaction in the random forest classifier for accurately predicting the flux-states. By analyzing the feature importance, the researchers can identify the reactions that have the most significant impact on distinguishing different flux-states.</a:t>
+            </a:r>
+            <a:endParaRPr lang="en-GB" sz="1400" dirty="0"/>
+          </a:p>
+        </p:txBody>
+      </p:sp>
+      <p:sp>
+        <p:nvSpPr>
+          <p:cNvPr id="4" name="Slide Number Placeholder 3"/>
           <p:cNvSpPr>
             <a:spLocks noGrp="1"/>
           </p:cNvSpPr>
@@ -12664,9 +12750,13 @@
         </p:txBody>
       </p:sp>
     </p:spTree>
+    <p:custDataLst>
+      <p:custData r:id="rId1"/>
+      <p:custData r:id="rId2"/>
+    </p:custDataLst>
     <p:extLst>
       <p:ext uri="{BB962C8B-B14F-4D97-AF65-F5344CB8AC3E}">
-        <p14:creationId xmlns:p14="http://schemas.microsoft.com/office/powerpoint/2010/main" val="275203181"/>
+        <p14:creationId xmlns:p14="http://schemas.microsoft.com/office/powerpoint/2010/main" val="1796381250"/>
       </p:ext>
     </p:extLst>
   </p:cSld>
@@ -12698,7 +12788,7 @@
           <p:cNvPr id="2" name="Title 1">
             <a:extLst>
               <a:ext uri="{FF2B5EF4-FFF2-40B4-BE49-F238E27FC236}">
-                <a16:creationId xmlns:a16="http://schemas.microsoft.com/office/drawing/2014/main" id="{D541482D-87FE-1B4E-3CEB-40A5C37F42C5}"/>
+                <a16:creationId xmlns:a16="http://schemas.microsoft.com/office/drawing/2014/main" id="{E0511799-4BB3-AD89-4D20-999AB8C5DB2B}"/>
               </a:ext>
             </a:extLst>
           </p:cNvPr>
@@ -12716,7 +12806,7 @@
           <a:p>
             <a:r>
               <a:rPr lang="en-US" dirty="0"/>
-              <a:t>Alternatives</a:t>
+              <a:t>Preserving interpretability while using PCA</a:t>
             </a:r>
             <a:endParaRPr lang="da-DK" dirty="0"/>
           </a:p>
@@ -12727,7 +12817,7 @@
           <p:cNvPr id="3" name="Content Placeholder 2">
             <a:extLst>
               <a:ext uri="{FF2B5EF4-FFF2-40B4-BE49-F238E27FC236}">
-                <a16:creationId xmlns:a16="http://schemas.microsoft.com/office/drawing/2014/main" id="{EE0175B4-1A9D-A025-141F-5E0A9A3A2044}"/>
+                <a16:creationId xmlns:a16="http://schemas.microsoft.com/office/drawing/2014/main" id="{6DC21131-EE78-651C-06D6-F4C3A24C68C8}"/>
               </a:ext>
             </a:extLst>
           </p:cNvPr>
@@ -12744,55 +12834,37 @@
           <a:lstStyle/>
           <a:p>
             <a:r>
-              <a:rPr lang="en-US" sz="1050" dirty="0"/>
-              <a:t>While the approach mentioned in the paper, combining clustering and random forests, can be effective for identifying relevant reactions, there are situations where alternative methods may be preferred. Here are a few reasons why you might consider using other techniques over clustering and random forests:</a:t>
-            </a:r>
-          </a:p>
-          <a:p>
-            <a:endParaRPr lang="en-US" sz="1050" dirty="0"/>
-          </a:p>
-          <a:p>
-            <a:r>
-              <a:rPr lang="en-US" sz="1050" dirty="0"/>
-              <a:t>Interpretability: Clustering alone may not provide explicit insights into the importance or contribution of individual reactions. It can group similar flux profiles together but might not reveal the specific reactions that drive the differences between clusters. Random forests help in identifying important features, but the interpretation might be limited to the context of the classifier. Other techniques like feature selection or dimensionality reduction methods with interpretability objectives can provide clearer insights into the specific reactions and their relevance.</a:t>
-            </a:r>
-          </a:p>
-          <a:p>
-            <a:endParaRPr lang="en-US" sz="1050" dirty="0"/>
-          </a:p>
-          <a:p>
-            <a:r>
-              <a:rPr lang="en-US" sz="1050" dirty="0"/>
-              <a:t>Dimensionality Reduction: If the dataset has a high number of features (e.g., hundreds or thousands of reactions), dimensionality reduction techniques like PCA, NMF, or Sparse PCA can be useful. These methods capture the essential information in a reduced-dimensional space while maintaining interpretability. By reducing the dimensionality, you can potentially mitigate issues related to the curse of dimensionality, improve computational efficiency, and focus on the most informative features.</a:t>
-            </a:r>
-          </a:p>
-          <a:p>
-            <a:endParaRPr lang="en-US" sz="1050" dirty="0"/>
-          </a:p>
-          <a:p>
-            <a:r>
-              <a:rPr lang="en-US" sz="1050" dirty="0"/>
-              <a:t>Alternative Machine Learning Algorithms: While random forests are widely used and offer good performance, it's worth exploring other machine learning algorithms as well. For example, support vector machines (SVM), gradient boosting, or deep learning techniques like neural networks may be suitable for the specific task of identifying relevant reactions. Different algorithms have varying strengths, and trying multiple methods can provide a comprehensive analysis and potentially better results for your specific dataset.</a:t>
-            </a:r>
-          </a:p>
-          <a:p>
-            <a:endParaRPr lang="en-US" sz="1050" dirty="0"/>
-          </a:p>
-          <a:p>
-            <a:r>
-              <a:rPr lang="en-US" sz="1050" dirty="0"/>
-              <a:t>Combination of Techniques: It's not necessarily an "either-or" choice between clustering and random forests versus alternative techniques. Instead, a combination of approaches can be beneficial. For example, you can use clustering to identify initial groups or patterns in the data, then apply other techniques like dimensionality reduction or feature selection within each cluster to identify important reactions. This hybrid approach can leverage the strengths of different methods and provide a more comprehensive analysis.</a:t>
-            </a:r>
-          </a:p>
-          <a:p>
-            <a:endParaRPr lang="en-US" sz="1050" dirty="0"/>
-          </a:p>
-          <a:p>
-            <a:r>
-              <a:rPr lang="en-US" sz="1050" dirty="0"/>
-              <a:t>Ultimately, the choice of techniques depends on the specific goals, characteristics of the data, and the interpretability requirements of your analysis. Exploring various options, combining methods, and considering the context of the problem can help you choose the most suitable techniques for your particular research or application.</a:t>
-            </a:r>
-            <a:endParaRPr lang="da-DK" sz="1050" dirty="0"/>
+              <a:rPr lang="en-US" sz="1200" dirty="0"/>
+              <a:t>Feature Selection: Instead of relying solely on PCA for dimensionality reduction, you can perform feature selection techniques specifically tailored for your task. These techniques aim to identify the most informative and relevant reactions for clustering and analysis. Some popular feature selection methods include mutual information, L1 regularization (Lasso), recursive feature elimination, or variance thresholding. By selecting a subset of important reactions, you can retain the interpretability of the original metabolic reactions without relying on a latent space representation.</a:t>
+            </a:r>
+          </a:p>
+          <a:p>
+            <a:endParaRPr lang="en-US" sz="1200" dirty="0"/>
+          </a:p>
+          <a:p>
+            <a:r>
+              <a:rPr lang="en-US" sz="1200" dirty="0"/>
+              <a:t>Interpretability-Aware Dimensionality Reduction: Explore alternative dimensionality reduction techniques that prioritize interpretability while reducing the feature space. For example, methods like Non-negative Matrix Factorization (NMF) or Sparse Principal Component Analysis (Sparse PCA) can provide reduced-dimensional representations while still allowing for interpretation in terms of the original metabolic reactions.</a:t>
+            </a:r>
+          </a:p>
+          <a:p>
+            <a:endParaRPr lang="en-US" sz="1200" dirty="0"/>
+          </a:p>
+          <a:p>
+            <a:r>
+              <a:rPr lang="en-US" sz="1200" dirty="0"/>
+              <a:t>Integration of PCA with Feature Importance: If PCA is used as a preliminary step, you can combine it with the analysis of feature importance obtained from the subsequent random forest classifier. After applying PCA, you can use the reduced-dimensional representation as input to the random forest classifier. The feature importance analysis can then be performed on the original metabolic reactions rather than the PCA-transformed features. This way, you can identify the important reactions in the context of the original representation while still benefiting from the dimensionality reduction provided by PCA.</a:t>
+            </a:r>
+          </a:p>
+          <a:p>
+            <a:endParaRPr lang="en-US" sz="1200" dirty="0"/>
+          </a:p>
+          <a:p>
+            <a:r>
+              <a:rPr lang="en-US" sz="1200" dirty="0"/>
+              <a:t>Domain Expertise and Biologically Driven Filtering: Consider incorporating domain expertise and biological knowledge to guide the preprocessing steps. For instance, you can apply additional filtering criteria based on known biochemical pathways, functional categories of reactions, or other relevant biological constraints. By leveraging domain expertise, you can refine the filtering process and focus on reactions that are biologically meaningful for your specific analysis.</a:t>
+            </a:r>
+            <a:endParaRPr lang="da-DK" sz="1200" dirty="0"/>
           </a:p>
         </p:txBody>
       </p:sp>
@@ -12801,7 +12873,7 @@
           <p:cNvPr id="4" name="Slide Number Placeholder 3">
             <a:extLst>
               <a:ext uri="{FF2B5EF4-FFF2-40B4-BE49-F238E27FC236}">
-                <a16:creationId xmlns:a16="http://schemas.microsoft.com/office/drawing/2014/main" id="{CB45D5BD-D590-A86B-6E5F-49994283D179}"/>
+                <a16:creationId xmlns:a16="http://schemas.microsoft.com/office/drawing/2014/main" id="{5B1668A1-BEBF-76F3-C92B-E0B6E5A9E46A}"/>
               </a:ext>
             </a:extLst>
           </p:cNvPr>
@@ -12829,7 +12901,7 @@
     </p:spTree>
     <p:extLst>
       <p:ext uri="{BB962C8B-B14F-4D97-AF65-F5344CB8AC3E}">
-        <p14:creationId xmlns:p14="http://schemas.microsoft.com/office/powerpoint/2010/main" val="2975768114"/>
+        <p14:creationId xmlns:p14="http://schemas.microsoft.com/office/powerpoint/2010/main" val="275203181"/>
       </p:ext>
     </p:extLst>
   </p:cSld>
@@ -12861,7 +12933,7 @@
           <p:cNvPr id="2" name="Title 1">
             <a:extLst>
               <a:ext uri="{FF2B5EF4-FFF2-40B4-BE49-F238E27FC236}">
-                <a16:creationId xmlns:a16="http://schemas.microsoft.com/office/drawing/2014/main" id="{734505B1-88E4-9529-FEBB-CCEA787A0643}"/>
+                <a16:creationId xmlns:a16="http://schemas.microsoft.com/office/drawing/2014/main" id="{D541482D-87FE-1B4E-3CEB-40A5C37F42C5}"/>
               </a:ext>
             </a:extLst>
           </p:cNvPr>
@@ -12879,7 +12951,7 @@
           <a:p>
             <a:r>
               <a:rPr lang="en-US" dirty="0"/>
-              <a:t>Analyzing Loadings</a:t>
+              <a:t>Alternatives</a:t>
             </a:r>
             <a:endParaRPr lang="da-DK" dirty="0"/>
           </a:p>
@@ -12890,7 +12962,7 @@
           <p:cNvPr id="3" name="Content Placeholder 2">
             <a:extLst>
               <a:ext uri="{FF2B5EF4-FFF2-40B4-BE49-F238E27FC236}">
-                <a16:creationId xmlns:a16="http://schemas.microsoft.com/office/drawing/2014/main" id="{74F2CD34-E267-7ABF-05E9-057796E18B32}"/>
+                <a16:creationId xmlns:a16="http://schemas.microsoft.com/office/drawing/2014/main" id="{EE0175B4-1A9D-A025-141F-5E0A9A3A2044}"/>
               </a:ext>
             </a:extLst>
           </p:cNvPr>
@@ -12906,94 +12978,56 @@
           <a:bodyPr/>
           <a:lstStyle/>
           <a:p>
-            <a:pPr algn="l"/>
-            <a:r>
-              <a:rPr lang="en-US" sz="1200" b="0" i="0" dirty="0">
-                <a:effectLst/>
-              </a:rPr>
-              <a:t>When the loadings in PCA are relatively close in magnitude, it suggests that multiple features (reactions in this case) contribute similarly to the corresponding principal component. In such situations, it can be challenging to distinguish the most important reactions solely based on the absolute values of the loadings.</a:t>
-            </a:r>
-          </a:p>
-          <a:p>
-            <a:pPr algn="l"/>
-            <a:r>
-              <a:rPr lang="en-US" sz="1200" b="0" i="0" dirty="0">
-                <a:effectLst/>
-              </a:rPr>
-              <a:t>To handle cases where the loadings are close, you can consider the following approaches:</a:t>
-            </a:r>
-          </a:p>
-          <a:p>
-            <a:pPr algn="l">
-              <a:buFont typeface="+mj-lt"/>
-              <a:buAutoNum type="arabicPeriod"/>
-            </a:pPr>
-            <a:r>
-              <a:rPr lang="en-US" sz="1200" b="0" i="0" dirty="0">
-                <a:effectLst/>
-              </a:rPr>
-              <a:t>Look for Consistency: Examine the loadings across multiple principal components. If a particular reaction consistently exhibits high loadings across multiple components, it indicates its importance in explaining the underlying variability in the dataset.</a:t>
-            </a:r>
-          </a:p>
-          <a:p>
-            <a:pPr algn="l">
-              <a:buFont typeface="+mj-lt"/>
-              <a:buAutoNum type="arabicPeriod"/>
-            </a:pPr>
-            <a:r>
-              <a:rPr lang="en-US" sz="1200" b="0" i="0" dirty="0">
-                <a:effectLst/>
-              </a:rPr>
-              <a:t>Consider Cumulative Explained Variance: Assess the cumulative explained variance ratio associated with each principal component. If a component contributes significantly to the cumulative explained variance, the reactions with relatively higher loadings in that component may be considered more important.</a:t>
-            </a:r>
-          </a:p>
-          <a:p>
-            <a:pPr algn="l">
-              <a:buFont typeface="+mj-lt"/>
-              <a:buAutoNum type="arabicPeriod"/>
-            </a:pPr>
-            <a:r>
-              <a:rPr lang="en-US" sz="1200" b="0" i="0" dirty="0">
-                <a:effectLst/>
-              </a:rPr>
-              <a:t>Analyze Patterns and Relationships: Instead of solely relying on the magnitude of loadings, examine the patterns and relationships among the loadings of different reactions. Look for groups of reactions with similar loadings, as they may collectively represent an important metabolic pathway or functional module.</a:t>
-            </a:r>
-          </a:p>
-          <a:p>
-            <a:pPr algn="l">
-              <a:buFont typeface="+mj-lt"/>
-              <a:buAutoNum type="arabicPeriod"/>
-            </a:pPr>
-            <a:r>
-              <a:rPr lang="en-US" sz="1200" b="0" i="0" dirty="0">
-                <a:effectLst/>
-              </a:rPr>
-              <a:t>Combine with Domain Knowledge: Incorporate prior domain knowledge, biological context, or existing literature to guide the interpretation of the loadings. Some reactions may have known functional significance or strong associations with the research problem, which can help prioritize their importance.</a:t>
-            </a:r>
-          </a:p>
-          <a:p>
-            <a:pPr algn="l">
-              <a:buFont typeface="+mj-lt"/>
-              <a:buAutoNum type="arabicPeriod"/>
-            </a:pPr>
-            <a:r>
-              <a:rPr lang="en-US" sz="1200" b="0" i="0" dirty="0">
-                <a:effectLst/>
-              </a:rPr>
-              <a:t>Perform Sensitivity Analysis: Explore the impact of varying the number of principal components used in the analysis. By including additional components, you may uncover subtle differences in the loadings that can help differentiate the importance of closely related reactions.</a:t>
-            </a:r>
-          </a:p>
-          <a:p>
-            <a:pPr algn="l"/>
-            <a:r>
-              <a:rPr lang="en-US" sz="1200" b="0" i="0" dirty="0">
-                <a:effectLst/>
-              </a:rPr>
-              <a:t>Remember that PCA is just one method for dimensionality reduction and feature analysis. If the closeness of loadings poses challenges in your analysis, you can consider alternative techniques such as sparse PCA, non-negative matrix factorization (NMF), or feature selection methods to further explore the importance of reactions in your research problem.</a:t>
-            </a:r>
-          </a:p>
-          <a:p>
-            <a:endParaRPr lang="da-DK" sz="1200" dirty="0"/>
+            <a:r>
+              <a:rPr lang="en-US" sz="1050" dirty="0"/>
+              <a:t>While the approach mentioned in the paper, combining clustering and random forests, can be effective for identifying relevant reactions, there are situations where alternative methods may be preferred. Here are a few reasons why you might consider using other techniques over clustering and random forests:</a:t>
+            </a:r>
+          </a:p>
+          <a:p>
+            <a:endParaRPr lang="en-US" sz="1050" dirty="0"/>
+          </a:p>
+          <a:p>
+            <a:r>
+              <a:rPr lang="en-US" sz="1050" dirty="0"/>
+              <a:t>Interpretability: Clustering alone may not provide explicit insights into the importance or contribution of individual reactions. It can group similar flux profiles together but might not reveal the specific reactions that drive the differences between clusters. Random forests help in identifying important features, but the interpretation might be limited to the context of the classifier. Other techniques like feature selection or dimensionality reduction methods with interpretability objectives can provide clearer insights into the specific reactions and their relevance.</a:t>
+            </a:r>
+          </a:p>
+          <a:p>
+            <a:endParaRPr lang="en-US" sz="1050" dirty="0"/>
+          </a:p>
+          <a:p>
+            <a:r>
+              <a:rPr lang="en-US" sz="1050" dirty="0"/>
+              <a:t>Dimensionality Reduction: If the dataset has a high number of features (e.g., hundreds or thousands of reactions), dimensionality reduction techniques like PCA, NMF, or Sparse PCA can be useful. These methods capture the essential information in a reduced-dimensional space while maintaining interpretability. By reducing the dimensionality, you can potentially mitigate issues related to the curse of dimensionality, improve computational efficiency, and focus on the most informative features.</a:t>
+            </a:r>
+          </a:p>
+          <a:p>
+            <a:endParaRPr lang="en-US" sz="1050" dirty="0"/>
+          </a:p>
+          <a:p>
+            <a:r>
+              <a:rPr lang="en-US" sz="1050" dirty="0"/>
+              <a:t>Alternative Machine Learning Algorithms: While random forests are widely used and offer good performance, it's worth exploring other machine learning algorithms as well. For example, support vector machines (SVM), gradient boosting, or deep learning techniques like neural networks may be suitable for the specific task of identifying relevant reactions. Different algorithms have varying strengths, and trying multiple methods can provide a comprehensive analysis and potentially better results for your specific dataset.</a:t>
+            </a:r>
+          </a:p>
+          <a:p>
+            <a:endParaRPr lang="en-US" sz="1050" dirty="0"/>
+          </a:p>
+          <a:p>
+            <a:r>
+              <a:rPr lang="en-US" sz="1050" dirty="0"/>
+              <a:t>Combination of Techniques: It's not necessarily an "either-or" choice between clustering and random forests versus alternative techniques. Instead, a combination of approaches can be beneficial. For example, you can use clustering to identify initial groups or patterns in the data, then apply other techniques like dimensionality reduction or feature selection within each cluster to identify important reactions. This hybrid approach can leverage the strengths of different methods and provide a more comprehensive analysis.</a:t>
+            </a:r>
+          </a:p>
+          <a:p>
+            <a:endParaRPr lang="en-US" sz="1050" dirty="0"/>
+          </a:p>
+          <a:p>
+            <a:r>
+              <a:rPr lang="en-US" sz="1050" dirty="0"/>
+              <a:t>Ultimately, the choice of techniques depends on the specific goals, characteristics of the data, and the interpretability requirements of your analysis. Exploring various options, combining methods, and considering the context of the problem can help you choose the most suitable techniques for your particular research or application.</a:t>
+            </a:r>
+            <a:endParaRPr lang="da-DK" sz="1050" dirty="0"/>
           </a:p>
         </p:txBody>
       </p:sp>
@@ -13002,7 +13036,7 @@
           <p:cNvPr id="4" name="Slide Number Placeholder 3">
             <a:extLst>
               <a:ext uri="{FF2B5EF4-FFF2-40B4-BE49-F238E27FC236}">
-                <a16:creationId xmlns:a16="http://schemas.microsoft.com/office/drawing/2014/main" id="{32392924-1379-009B-3BB7-F5F1D18C4228}"/>
+                <a16:creationId xmlns:a16="http://schemas.microsoft.com/office/drawing/2014/main" id="{CB45D5BD-D590-A86B-6E5F-49994283D179}"/>
               </a:ext>
             </a:extLst>
           </p:cNvPr>
@@ -13030,7 +13064,7 @@
     </p:spTree>
     <p:extLst>
       <p:ext uri="{BB962C8B-B14F-4D97-AF65-F5344CB8AC3E}">
-        <p14:creationId xmlns:p14="http://schemas.microsoft.com/office/powerpoint/2010/main" val="3106625368"/>
+        <p14:creationId xmlns:p14="http://schemas.microsoft.com/office/powerpoint/2010/main" val="2975768114"/>
       </p:ext>
     </p:extLst>
   </p:cSld>
@@ -13338,7 +13372,7 @@
           <p:cNvPr id="2" name="Title 1">
             <a:extLst>
               <a:ext uri="{FF2B5EF4-FFF2-40B4-BE49-F238E27FC236}">
-                <a16:creationId xmlns:a16="http://schemas.microsoft.com/office/drawing/2014/main" id="{9D24FBDB-FF20-78DB-6AFB-27F214AF0415}"/>
+                <a16:creationId xmlns:a16="http://schemas.microsoft.com/office/drawing/2014/main" id="{734505B1-88E4-9529-FEBB-CCEA787A0643}"/>
               </a:ext>
             </a:extLst>
           </p:cNvPr>
@@ -13356,7 +13390,7 @@
           <a:p>
             <a:r>
               <a:rPr lang="en-US" dirty="0"/>
-              <a:t>Cell Lifelines</a:t>
+              <a:t>Analyzing Loadings</a:t>
             </a:r>
             <a:endParaRPr lang="da-DK" dirty="0"/>
           </a:p>
@@ -13367,7 +13401,7 @@
           <p:cNvPr id="3" name="Content Placeholder 2">
             <a:extLst>
               <a:ext uri="{FF2B5EF4-FFF2-40B4-BE49-F238E27FC236}">
-                <a16:creationId xmlns:a16="http://schemas.microsoft.com/office/drawing/2014/main" id="{DD7A7ADE-D22D-9459-1970-9554AF922C9B}"/>
+                <a16:creationId xmlns:a16="http://schemas.microsoft.com/office/drawing/2014/main" id="{74F2CD34-E267-7ABF-05E9-057796E18B32}"/>
               </a:ext>
             </a:extLst>
           </p:cNvPr>
@@ -13385,37 +13419,19 @@
           <a:p>
             <a:pPr algn="l"/>
             <a:r>
-              <a:rPr lang="en-US" sz="1400" b="0" i="0" dirty="0">
-                <a:solidFill>
-                  <a:srgbClr val="374151"/>
-                </a:solidFill>
-                <a:effectLst/>
-              </a:rPr>
-              <a:t>If your cell lifelines data has thousands of time points but only 4 columns (x, y, z, and substrate concentration), it means that you have high-dimensional data with a large number of observations. In this case, using PCA with 4 components will not be suitable for dimensionality reduction because you are already using all the available columns.</a:t>
+              <a:rPr lang="en-US" sz="1200" b="0" i="0" dirty="0">
+                <a:effectLst/>
+              </a:rPr>
+              <a:t>When the loadings in PCA are relatively close in magnitude, it suggests that multiple features (reactions in this case) contribute similarly to the corresponding principal component. In such situations, it can be challenging to distinguish the most important reactions solely based on the absolute values of the loadings.</a:t>
             </a:r>
           </a:p>
           <a:p>
             <a:pPr algn="l"/>
             <a:r>
-              <a:rPr lang="en-US" sz="1400" b="0" i="0" dirty="0">
-                <a:solidFill>
-                  <a:srgbClr val="374151"/>
-                </a:solidFill>
-                <a:effectLst/>
-              </a:rPr>
-              <a:t>PCA is primarily used to reduce the dimensionality of data by capturing the most significant variations in the dataset. If you want to reduce the number of rows (observations) while retaining the 4 columns, you can consider alternative techniques such as sampling or filtering methods.</a:t>
-            </a:r>
-          </a:p>
-          <a:p>
-            <a:pPr algn="l"/>
-            <a:r>
-              <a:rPr lang="en-US" sz="1400" b="0" i="0" dirty="0">
-                <a:solidFill>
-                  <a:srgbClr val="374151"/>
-                </a:solidFill>
-                <a:effectLst/>
-              </a:rPr>
-              <a:t>Here are a couple of approaches you can consider:</a:t>
+              <a:rPr lang="en-US" sz="1200" b="0" i="0" dirty="0">
+                <a:effectLst/>
+              </a:rPr>
+              <a:t>To handle cases where the loadings are close, you can consider the following approaches:</a:t>
             </a:r>
           </a:p>
           <a:p>
@@ -13424,13 +13440,10 @@
               <a:buAutoNum type="arabicPeriod"/>
             </a:pPr>
             <a:r>
-              <a:rPr lang="en-US" sz="1400" b="0" i="0" dirty="0">
-                <a:solidFill>
-                  <a:srgbClr val="374151"/>
-                </a:solidFill>
-                <a:effectLst/>
-              </a:rPr>
-              <a:t>Sampling: If the number of time points is too large and you want to reduce the dataset while preserving the overall distribution of the data, you can use random sampling techniques. Randomly select a subset of time points from the dataset that adequately represents the overall behavior. This will reduce the number of rows while retaining the original columns.</a:t>
+              <a:rPr lang="en-US" sz="1200" b="0" i="0" dirty="0">
+                <a:effectLst/>
+              </a:rPr>
+              <a:t>Look for Consistency: Examine the loadings across multiple principal components. If a particular reaction consistently exhibits high loadings across multiple components, it indicates its importance in explaining the underlying variability in the dataset.</a:t>
             </a:r>
           </a:p>
           <a:p>
@@ -13439,41 +13452,59 @@
               <a:buAutoNum type="arabicPeriod"/>
             </a:pPr>
             <a:r>
-              <a:rPr lang="en-US" sz="1400" b="0" i="0" dirty="0">
-                <a:solidFill>
-                  <a:srgbClr val="374151"/>
-                </a:solidFill>
-                <a:effectLst/>
-              </a:rPr>
-              <a:t>Filtering: If there are specific criteria or patterns you want to consider for selecting time points, you can apply filtering techniques. For example, you can filter out time points that fall within a certain range or meet specific conditions based on the substrate concentration or other relevant factors.</a:t>
+              <a:rPr lang="en-US" sz="1200" b="0" i="0" dirty="0">
+                <a:effectLst/>
+              </a:rPr>
+              <a:t>Consider Cumulative Explained Variance: Assess the cumulative explained variance ratio associated with each principal component. If a component contributes significantly to the cumulative explained variance, the reactions with relatively higher loadings in that component may be considered more important.</a:t>
+            </a:r>
+          </a:p>
+          <a:p>
+            <a:pPr algn="l">
+              <a:buFont typeface="+mj-lt"/>
+              <a:buAutoNum type="arabicPeriod"/>
+            </a:pPr>
+            <a:r>
+              <a:rPr lang="en-US" sz="1200" b="0" i="0" dirty="0">
+                <a:effectLst/>
+              </a:rPr>
+              <a:t>Analyze Patterns and Relationships: Instead of solely relying on the magnitude of loadings, examine the patterns and relationships among the loadings of different reactions. Look for groups of reactions with similar loadings, as they may collectively represent an important metabolic pathway or functional module.</a:t>
+            </a:r>
+          </a:p>
+          <a:p>
+            <a:pPr algn="l">
+              <a:buFont typeface="+mj-lt"/>
+              <a:buAutoNum type="arabicPeriod"/>
+            </a:pPr>
+            <a:r>
+              <a:rPr lang="en-US" sz="1200" b="0" i="0" dirty="0">
+                <a:effectLst/>
+              </a:rPr>
+              <a:t>Combine with Domain Knowledge: Incorporate prior domain knowledge, biological context, or existing literature to guide the interpretation of the loadings. Some reactions may have known functional significance or strong associations with the research problem, which can help prioritize their importance.</a:t>
+            </a:r>
+          </a:p>
+          <a:p>
+            <a:pPr algn="l">
+              <a:buFont typeface="+mj-lt"/>
+              <a:buAutoNum type="arabicPeriod"/>
+            </a:pPr>
+            <a:r>
+              <a:rPr lang="en-US" sz="1200" b="0" i="0" dirty="0">
+                <a:effectLst/>
+              </a:rPr>
+              <a:t>Perform Sensitivity Analysis: Explore the impact of varying the number of principal components used in the analysis. By including additional components, you may uncover subtle differences in the loadings that can help differentiate the importance of closely related reactions.</a:t>
             </a:r>
           </a:p>
           <a:p>
             <a:pPr algn="l"/>
             <a:r>
-              <a:rPr lang="en-US" sz="1400" b="0" i="0" dirty="0">
-                <a:solidFill>
-                  <a:srgbClr val="374151"/>
-                </a:solidFill>
-                <a:effectLst/>
-              </a:rPr>
-              <a:t>Both sampling and filtering methods can help you reduce the number of rows in your dataset while retaining the original columns of interest (x, y, z, and substrate concentration). After reducing the dataset, you can then perform PCA or other analyses as needed.</a:t>
-            </a:r>
-          </a:p>
-          <a:p>
-            <a:pPr algn="l"/>
-            <a:r>
-              <a:rPr lang="en-US" sz="1400" b="0" i="0" dirty="0">
-                <a:solidFill>
-                  <a:srgbClr val="374151"/>
-                </a:solidFill>
-                <a:effectLst/>
-              </a:rPr>
-              <a:t>Remember to consider the implications of reducing the dataset on the representativeness and generalizability of your results. It's important to ensure that the reduced dataset still captures the essential characteristics and patterns of the original data.</a:t>
-            </a:r>
-          </a:p>
-          <a:p>
-            <a:endParaRPr lang="da-DK" sz="1400" dirty="0"/>
+              <a:rPr lang="en-US" sz="1200" b="0" i="0" dirty="0">
+                <a:effectLst/>
+              </a:rPr>
+              <a:t>Remember that PCA is just one method for dimensionality reduction and feature analysis. If the closeness of loadings poses challenges in your analysis, you can consider alternative techniques such as sparse PCA, non-negative matrix factorization (NMF), or feature selection methods to further explore the importance of reactions in your research problem.</a:t>
+            </a:r>
+          </a:p>
+          <a:p>
+            <a:endParaRPr lang="da-DK" sz="1200" dirty="0"/>
           </a:p>
         </p:txBody>
       </p:sp>
@@ -13482,7 +13513,7 @@
           <p:cNvPr id="4" name="Slide Number Placeholder 3">
             <a:extLst>
               <a:ext uri="{FF2B5EF4-FFF2-40B4-BE49-F238E27FC236}">
-                <a16:creationId xmlns:a16="http://schemas.microsoft.com/office/drawing/2014/main" id="{FA5818B6-F499-C20E-4DC2-B110C0C28CD1}"/>
+                <a16:creationId xmlns:a16="http://schemas.microsoft.com/office/drawing/2014/main" id="{32392924-1379-009B-3BB7-F5F1D18C4228}"/>
               </a:ext>
             </a:extLst>
           </p:cNvPr>
@@ -13510,7 +13541,7 @@
     </p:spTree>
     <p:extLst>
       <p:ext uri="{BB962C8B-B14F-4D97-AF65-F5344CB8AC3E}">
-        <p14:creationId xmlns:p14="http://schemas.microsoft.com/office/powerpoint/2010/main" val="501034683"/>
+        <p14:creationId xmlns:p14="http://schemas.microsoft.com/office/powerpoint/2010/main" val="3106625368"/>
       </p:ext>
     </p:extLst>
   </p:cSld>
@@ -13542,6 +13573,210 @@
           <p:cNvPr id="2" name="Title 1">
             <a:extLst>
               <a:ext uri="{FF2B5EF4-FFF2-40B4-BE49-F238E27FC236}">
+                <a16:creationId xmlns:a16="http://schemas.microsoft.com/office/drawing/2014/main" id="{9D24FBDB-FF20-78DB-6AFB-27F214AF0415}"/>
+              </a:ext>
+            </a:extLst>
+          </p:cNvPr>
+          <p:cNvSpPr>
+            <a:spLocks noGrp="1"/>
+          </p:cNvSpPr>
+          <p:nvPr>
+            <p:ph type="title"/>
+          </p:nvPr>
+        </p:nvSpPr>
+        <p:spPr/>
+        <p:txBody>
+          <a:bodyPr/>
+          <a:lstStyle/>
+          <a:p>
+            <a:r>
+              <a:rPr lang="en-US" dirty="0"/>
+              <a:t>Cell Lifelines</a:t>
+            </a:r>
+            <a:endParaRPr lang="da-DK" dirty="0"/>
+          </a:p>
+        </p:txBody>
+      </p:sp>
+      <p:sp>
+        <p:nvSpPr>
+          <p:cNvPr id="3" name="Content Placeholder 2">
+            <a:extLst>
+              <a:ext uri="{FF2B5EF4-FFF2-40B4-BE49-F238E27FC236}">
+                <a16:creationId xmlns:a16="http://schemas.microsoft.com/office/drawing/2014/main" id="{DD7A7ADE-D22D-9459-1970-9554AF922C9B}"/>
+              </a:ext>
+            </a:extLst>
+          </p:cNvPr>
+          <p:cNvSpPr>
+            <a:spLocks noGrp="1"/>
+          </p:cNvSpPr>
+          <p:nvPr>
+            <p:ph idx="1"/>
+          </p:nvPr>
+        </p:nvSpPr>
+        <p:spPr/>
+        <p:txBody>
+          <a:bodyPr/>
+          <a:lstStyle/>
+          <a:p>
+            <a:pPr algn="l"/>
+            <a:r>
+              <a:rPr lang="en-US" sz="1400" b="0" i="0" dirty="0">
+                <a:solidFill>
+                  <a:srgbClr val="374151"/>
+                </a:solidFill>
+                <a:effectLst/>
+              </a:rPr>
+              <a:t>If your cell lifelines data has thousands of time points but only 4 columns (x, y, z, and substrate concentration), it means that you have high-dimensional data with a large number of observations. In this case, using PCA with 4 components will not be suitable for dimensionality reduction because you are already using all the available columns.</a:t>
+            </a:r>
+          </a:p>
+          <a:p>
+            <a:pPr algn="l"/>
+            <a:r>
+              <a:rPr lang="en-US" sz="1400" b="0" i="0" dirty="0">
+                <a:solidFill>
+                  <a:srgbClr val="374151"/>
+                </a:solidFill>
+                <a:effectLst/>
+              </a:rPr>
+              <a:t>PCA is primarily used to reduce the dimensionality of data by capturing the most significant variations in the dataset. If you want to reduce the number of rows (observations) while retaining the 4 columns, you can consider alternative techniques such as sampling or filtering methods.</a:t>
+            </a:r>
+          </a:p>
+          <a:p>
+            <a:pPr algn="l"/>
+            <a:r>
+              <a:rPr lang="en-US" sz="1400" b="0" i="0" dirty="0">
+                <a:solidFill>
+                  <a:srgbClr val="374151"/>
+                </a:solidFill>
+                <a:effectLst/>
+              </a:rPr>
+              <a:t>Here are a couple of approaches you can consider:</a:t>
+            </a:r>
+          </a:p>
+          <a:p>
+            <a:pPr algn="l">
+              <a:buFont typeface="+mj-lt"/>
+              <a:buAutoNum type="arabicPeriod"/>
+            </a:pPr>
+            <a:r>
+              <a:rPr lang="en-US" sz="1400" b="0" i="0" dirty="0">
+                <a:solidFill>
+                  <a:srgbClr val="374151"/>
+                </a:solidFill>
+                <a:effectLst/>
+              </a:rPr>
+              <a:t>Sampling: If the number of time points is too large and you want to reduce the dataset while preserving the overall distribution of the data, you can use random sampling techniques. Randomly select a subset of time points from the dataset that adequately represents the overall behavior. This will reduce the number of rows while retaining the original columns.</a:t>
+            </a:r>
+          </a:p>
+          <a:p>
+            <a:pPr algn="l">
+              <a:buFont typeface="+mj-lt"/>
+              <a:buAutoNum type="arabicPeriod"/>
+            </a:pPr>
+            <a:r>
+              <a:rPr lang="en-US" sz="1400" b="0" i="0" dirty="0">
+                <a:solidFill>
+                  <a:srgbClr val="374151"/>
+                </a:solidFill>
+                <a:effectLst/>
+              </a:rPr>
+              <a:t>Filtering: If there are specific criteria or patterns you want to consider for selecting time points, you can apply filtering techniques. For example, you can filter out time points that fall within a certain range or meet specific conditions based on the substrate concentration or other relevant factors.</a:t>
+            </a:r>
+          </a:p>
+          <a:p>
+            <a:pPr algn="l"/>
+            <a:r>
+              <a:rPr lang="en-US" sz="1400" b="0" i="0" dirty="0">
+                <a:solidFill>
+                  <a:srgbClr val="374151"/>
+                </a:solidFill>
+                <a:effectLst/>
+              </a:rPr>
+              <a:t>Both sampling and filtering methods can help you reduce the number of rows in your dataset while retaining the original columns of interest (x, y, z, and substrate concentration). After reducing the dataset, you can then perform PCA or other analyses as needed.</a:t>
+            </a:r>
+          </a:p>
+          <a:p>
+            <a:pPr algn="l"/>
+            <a:r>
+              <a:rPr lang="en-US" sz="1400" b="0" i="0" dirty="0">
+                <a:solidFill>
+                  <a:srgbClr val="374151"/>
+                </a:solidFill>
+                <a:effectLst/>
+              </a:rPr>
+              <a:t>Remember to consider the implications of reducing the dataset on the representativeness and generalizability of your results. It's important to ensure that the reduced dataset still captures the essential characteristics and patterns of the original data.</a:t>
+            </a:r>
+          </a:p>
+          <a:p>
+            <a:endParaRPr lang="da-DK" sz="1400" dirty="0"/>
+          </a:p>
+        </p:txBody>
+      </p:sp>
+      <p:sp>
+        <p:nvSpPr>
+          <p:cNvPr id="4" name="Slide Number Placeholder 3">
+            <a:extLst>
+              <a:ext uri="{FF2B5EF4-FFF2-40B4-BE49-F238E27FC236}">
+                <a16:creationId xmlns:a16="http://schemas.microsoft.com/office/drawing/2014/main" id="{FA5818B6-F499-C20E-4DC2-B110C0C28CD1}"/>
+              </a:ext>
+            </a:extLst>
+          </p:cNvPr>
+          <p:cNvSpPr>
+            <a:spLocks noGrp="1"/>
+          </p:cNvSpPr>
+          <p:nvPr>
+            <p:ph type="sldNum" sz="quarter" idx="11"/>
+          </p:nvPr>
+        </p:nvSpPr>
+        <p:spPr/>
+        <p:txBody>
+          <a:bodyPr/>
+          <a:lstStyle/>
+          <a:p>
+            <a:fld id="{103EA872-A674-449B-A120-B97244F8E91D}" type="slidenum">
+              <a:rPr lang="en-GB" smtClean="0"/>
+              <a:pPr/>
+              <a:t>31</a:t>
+            </a:fld>
+            <a:endParaRPr lang="en-GB" dirty="0"/>
+          </a:p>
+        </p:txBody>
+      </p:sp>
+    </p:spTree>
+    <p:extLst>
+      <p:ext uri="{BB962C8B-B14F-4D97-AF65-F5344CB8AC3E}">
+        <p14:creationId xmlns:p14="http://schemas.microsoft.com/office/powerpoint/2010/main" val="501034683"/>
+      </p:ext>
+    </p:extLst>
+  </p:cSld>
+  <p:clrMapOvr>
+    <a:masterClrMapping/>
+  </p:clrMapOvr>
+</p:sld>
+</file>
+
+<file path=ppt/slides/slide32.xml><?xml version="1.0" encoding="utf-8"?>
+<p:sld xmlns:a="http://schemas.openxmlformats.org/drawingml/2006/main" xmlns:r="http://schemas.openxmlformats.org/officeDocument/2006/relationships" xmlns:p="http://schemas.openxmlformats.org/presentationml/2006/main">
+  <p:cSld>
+    <p:spTree>
+      <p:nvGrpSpPr>
+        <p:cNvPr id="1" name=""/>
+        <p:cNvGrpSpPr/>
+        <p:nvPr/>
+      </p:nvGrpSpPr>
+      <p:grpSpPr>
+        <a:xfrm>
+          <a:off x="0" y="0"/>
+          <a:ext cx="0" cy="0"/>
+          <a:chOff x="0" y="0"/>
+          <a:chExt cx="0" cy="0"/>
+        </a:xfrm>
+      </p:grpSpPr>
+      <p:sp>
+        <p:nvSpPr>
+          <p:cNvPr id="2" name="Title 1">
+            <a:extLst>
+              <a:ext uri="{FF2B5EF4-FFF2-40B4-BE49-F238E27FC236}">
                 <a16:creationId xmlns:a16="http://schemas.microsoft.com/office/drawing/2014/main" id="{5D47D844-D950-9687-267F-CAF49329064C}"/>
               </a:ext>
             </a:extLst>
@@ -13768,7 +14003,7 @@
             <a:fld id="{103EA872-A674-449B-A120-B97244F8E91D}" type="slidenum">
               <a:rPr lang="en-GB" smtClean="0"/>
               <a:pPr/>
-              <a:t>31</a:t>
+              <a:t>32</a:t>
             </a:fld>
             <a:endParaRPr lang="en-GB" dirty="0"/>
           </a:p>
@@ -13778,6 +14013,582 @@
     <p:extLst>
       <p:ext uri="{BB962C8B-B14F-4D97-AF65-F5344CB8AC3E}">
         <p14:creationId xmlns:p14="http://schemas.microsoft.com/office/powerpoint/2010/main" val="4003857432"/>
+      </p:ext>
+    </p:extLst>
+  </p:cSld>
+  <p:clrMapOvr>
+    <a:masterClrMapping/>
+  </p:clrMapOvr>
+</p:sld>
+</file>
+
+<file path=ppt/slides/slide33.xml><?xml version="1.0" encoding="utf-8"?>
+<p:sld xmlns:a="http://schemas.openxmlformats.org/drawingml/2006/main" xmlns:r="http://schemas.openxmlformats.org/officeDocument/2006/relationships" xmlns:p="http://schemas.openxmlformats.org/presentationml/2006/main">
+  <p:cSld>
+    <p:spTree>
+      <p:nvGrpSpPr>
+        <p:cNvPr id="1" name=""/>
+        <p:cNvGrpSpPr/>
+        <p:nvPr/>
+      </p:nvGrpSpPr>
+      <p:grpSpPr>
+        <a:xfrm>
+          <a:off x="0" y="0"/>
+          <a:ext cx="0" cy="0"/>
+          <a:chOff x="0" y="0"/>
+          <a:chExt cx="0" cy="0"/>
+        </a:xfrm>
+      </p:grpSpPr>
+      <p:sp>
+        <p:nvSpPr>
+          <p:cNvPr id="2" name="Title 1">
+            <a:extLst>
+              <a:ext uri="{FF2B5EF4-FFF2-40B4-BE49-F238E27FC236}">
+                <a16:creationId xmlns:a16="http://schemas.microsoft.com/office/drawing/2014/main" id="{F0F072BA-15AB-A06E-F068-5D97E092B912}"/>
+              </a:ext>
+            </a:extLst>
+          </p:cNvPr>
+          <p:cNvSpPr>
+            <a:spLocks noGrp="1"/>
+          </p:cNvSpPr>
+          <p:nvPr>
+            <p:ph type="title"/>
+          </p:nvPr>
+        </p:nvSpPr>
+        <p:spPr/>
+        <p:txBody>
+          <a:bodyPr/>
+          <a:lstStyle/>
+          <a:p>
+            <a:endParaRPr lang="da-DK" dirty="0"/>
+          </a:p>
+        </p:txBody>
+      </p:sp>
+      <p:sp>
+        <p:nvSpPr>
+          <p:cNvPr id="3" name="Content Placeholder 2">
+            <a:extLst>
+              <a:ext uri="{FF2B5EF4-FFF2-40B4-BE49-F238E27FC236}">
+                <a16:creationId xmlns:a16="http://schemas.microsoft.com/office/drawing/2014/main" id="{4BE04EF9-98E8-A355-BBEC-4448F145A8E6}"/>
+              </a:ext>
+            </a:extLst>
+          </p:cNvPr>
+          <p:cNvSpPr>
+            <a:spLocks noGrp="1"/>
+          </p:cNvSpPr>
+          <p:nvPr>
+            <p:ph idx="1"/>
+          </p:nvPr>
+        </p:nvSpPr>
+        <p:spPr/>
+        <p:txBody>
+          <a:bodyPr/>
+          <a:lstStyle/>
+          <a:p>
+            <a:r>
+              <a:rPr lang="en-US" b="0" i="0" dirty="0">
+                <a:solidFill>
+                  <a:srgbClr val="374151"/>
+                </a:solidFill>
+                <a:effectLst/>
+                <a:latin typeface="+mj-lt"/>
+              </a:rPr>
+              <a:t>Predictive Modeling: Autoencoders can be extended to include additional layers beyond the decoder. By incorporating supervised learning techniques, such as adding classification or regression layers on top of the autoencoder architecture, the learned features can be used for predictive modeling tasks. The encoder captures meaningful representations of the cell lifeline data, which can aid in predicting specific outcomes or properties of interest.</a:t>
+            </a:r>
+          </a:p>
+          <a:p>
+            <a:endParaRPr lang="da-DK" dirty="0">
+              <a:latin typeface="+mj-lt"/>
+            </a:endParaRPr>
+          </a:p>
+        </p:txBody>
+      </p:sp>
+      <p:sp>
+        <p:nvSpPr>
+          <p:cNvPr id="4" name="Slide Number Placeholder 3">
+            <a:extLst>
+              <a:ext uri="{FF2B5EF4-FFF2-40B4-BE49-F238E27FC236}">
+                <a16:creationId xmlns:a16="http://schemas.microsoft.com/office/drawing/2014/main" id="{3CAA5A6A-B9FE-C8EE-6D27-1E49CEC1E775}"/>
+              </a:ext>
+            </a:extLst>
+          </p:cNvPr>
+          <p:cNvSpPr>
+            <a:spLocks noGrp="1"/>
+          </p:cNvSpPr>
+          <p:nvPr>
+            <p:ph type="sldNum" sz="quarter" idx="11"/>
+          </p:nvPr>
+        </p:nvSpPr>
+        <p:spPr/>
+        <p:txBody>
+          <a:bodyPr/>
+          <a:lstStyle/>
+          <a:p>
+            <a:fld id="{103EA872-A674-449B-A120-B97244F8E91D}" type="slidenum">
+              <a:rPr lang="en-GB" smtClean="0"/>
+              <a:pPr/>
+              <a:t>33</a:t>
+            </a:fld>
+            <a:endParaRPr lang="en-GB" dirty="0"/>
+          </a:p>
+        </p:txBody>
+      </p:sp>
+    </p:spTree>
+    <p:extLst>
+      <p:ext uri="{BB962C8B-B14F-4D97-AF65-F5344CB8AC3E}">
+        <p14:creationId xmlns:p14="http://schemas.microsoft.com/office/powerpoint/2010/main" val="2982816725"/>
+      </p:ext>
+    </p:extLst>
+  </p:cSld>
+  <p:clrMapOvr>
+    <a:masterClrMapping/>
+  </p:clrMapOvr>
+</p:sld>
+</file>
+
+<file path=ppt/slides/slide34.xml><?xml version="1.0" encoding="utf-8"?>
+<p:sld xmlns:a="http://schemas.openxmlformats.org/drawingml/2006/main" xmlns:r="http://schemas.openxmlformats.org/officeDocument/2006/relationships" xmlns:p="http://schemas.openxmlformats.org/presentationml/2006/main">
+  <p:cSld>
+    <p:spTree>
+      <p:nvGrpSpPr>
+        <p:cNvPr id="1" name=""/>
+        <p:cNvGrpSpPr/>
+        <p:nvPr/>
+      </p:nvGrpSpPr>
+      <p:grpSpPr>
+        <a:xfrm>
+          <a:off x="0" y="0"/>
+          <a:ext cx="0" cy="0"/>
+          <a:chOff x="0" y="0"/>
+          <a:chExt cx="0" cy="0"/>
+        </a:xfrm>
+      </p:grpSpPr>
+      <p:sp>
+        <p:nvSpPr>
+          <p:cNvPr id="2" name="Title 1">
+            <a:extLst>
+              <a:ext uri="{FF2B5EF4-FFF2-40B4-BE49-F238E27FC236}">
+                <a16:creationId xmlns:a16="http://schemas.microsoft.com/office/drawing/2014/main" id="{24B1D29F-BE75-C5DB-B74E-AF092621385C}"/>
+              </a:ext>
+            </a:extLst>
+          </p:cNvPr>
+          <p:cNvSpPr>
+            <a:spLocks noGrp="1"/>
+          </p:cNvSpPr>
+          <p:nvPr>
+            <p:ph type="title"/>
+          </p:nvPr>
+        </p:nvSpPr>
+        <p:spPr/>
+        <p:txBody>
+          <a:bodyPr/>
+          <a:lstStyle/>
+          <a:p>
+            <a:r>
+              <a:rPr lang="en-US" dirty="0"/>
+              <a:t>Autoencoders &amp; Metabolic Networks</a:t>
+            </a:r>
+            <a:endParaRPr lang="da-DK" dirty="0"/>
+          </a:p>
+        </p:txBody>
+      </p:sp>
+      <p:sp>
+        <p:nvSpPr>
+          <p:cNvPr id="3" name="Content Placeholder 2">
+            <a:extLst>
+              <a:ext uri="{FF2B5EF4-FFF2-40B4-BE49-F238E27FC236}">
+                <a16:creationId xmlns:a16="http://schemas.microsoft.com/office/drawing/2014/main" id="{EA318381-9B42-27F0-E957-EBAC624824BF}"/>
+              </a:ext>
+            </a:extLst>
+          </p:cNvPr>
+          <p:cNvSpPr>
+            <a:spLocks noGrp="1"/>
+          </p:cNvSpPr>
+          <p:nvPr>
+            <p:ph idx="1"/>
+          </p:nvPr>
+        </p:nvSpPr>
+        <p:spPr/>
+        <p:txBody>
+          <a:bodyPr/>
+          <a:lstStyle/>
+          <a:p>
+            <a:pPr algn="l"/>
+            <a:r>
+              <a:rPr lang="en-US" sz="1100" b="0" i="0" dirty="0">
+                <a:solidFill>
+                  <a:srgbClr val="374151"/>
+                </a:solidFill>
+                <a:effectLst/>
+                <a:latin typeface="+mj-lt"/>
+              </a:rPr>
+              <a:t>Autoencoders can provide valuable insights into cell lifelines and metabolic networks by learning compact and meaningful representations of the underlying data. Here are some ways in which autoencoders can help us gain information about cell lifelines and metabolic networks:</a:t>
+            </a:r>
+          </a:p>
+          <a:p>
+            <a:pPr algn="l">
+              <a:buFont typeface="+mj-lt"/>
+              <a:buAutoNum type="arabicPeriod"/>
+            </a:pPr>
+            <a:r>
+              <a:rPr lang="en-US" sz="1100" b="0" i="0" dirty="0">
+                <a:solidFill>
+                  <a:srgbClr val="374151"/>
+                </a:solidFill>
+                <a:effectLst/>
+                <a:latin typeface="+mj-lt"/>
+              </a:rPr>
+              <a:t>Reconstruction of Cell Lifelines: Autoencoders are trained to reconstruct their input data from compressed latent representations. By training an autoencoder on cell lifeline data, the decoder part of the autoencoder can generate reconstructed lifelines that closely resemble the original input. Comparing the reconstructed lifelines with the original ones can help identify patterns, similarities, and differences. This can provide insights into the dynamics and variations within the lifelines and help uncover underlying regulatory mechanisms.</a:t>
+            </a:r>
+          </a:p>
+          <a:p>
+            <a:pPr algn="l">
+              <a:buFont typeface="+mj-lt"/>
+              <a:buAutoNum type="arabicPeriod"/>
+            </a:pPr>
+            <a:r>
+              <a:rPr lang="en-US" sz="1100" b="0" i="0" dirty="0">
+                <a:solidFill>
+                  <a:srgbClr val="374151"/>
+                </a:solidFill>
+                <a:effectLst/>
+                <a:latin typeface="+mj-lt"/>
+              </a:rPr>
+              <a:t>Feature Extraction: The encoder part of an autoencoder learns to extract the most salient features from the input data. In the context of cell lifelines, this can include identifying important metabolites, proteins, or gene expressions that contribute significantly to the observed variations. By analyzing the learned latent space, we can gain insights into the most informative features and their relationships, which can aid in understanding the underlying biology and metabolic processes.</a:t>
+            </a:r>
+          </a:p>
+          <a:p>
+            <a:pPr algn="l">
+              <a:buFont typeface="+mj-lt"/>
+              <a:buAutoNum type="arabicPeriod"/>
+            </a:pPr>
+            <a:r>
+              <a:rPr lang="en-US" sz="1100" b="0" i="0" dirty="0">
+                <a:solidFill>
+                  <a:srgbClr val="374151"/>
+                </a:solidFill>
+                <a:effectLst/>
+                <a:latin typeface="+mj-lt"/>
+              </a:rPr>
+              <a:t>Anomaly Detection: Autoencoders can be used to detect anomalies or deviations from normal cell lifelines. By training an autoencoder on a dataset of healthy or normal lifelines, it can learn to reconstruct normal patterns. When presented with anomalous lifelines, the autoencoder will have higher reconstruction errors, indicating a deviation from the normal behavior. This can help identify aberrations in metabolic networks or cell lifelines, which may indicate disease conditions, drug responses, or other important phenomena.</a:t>
+            </a:r>
+          </a:p>
+          <a:p>
+            <a:pPr algn="l">
+              <a:buFont typeface="+mj-lt"/>
+              <a:buAutoNum type="arabicPeriod"/>
+            </a:pPr>
+            <a:r>
+              <a:rPr lang="en-US" sz="1100" b="0" i="0" dirty="0">
+                <a:solidFill>
+                  <a:srgbClr val="374151"/>
+                </a:solidFill>
+                <a:effectLst/>
+                <a:latin typeface="+mj-lt"/>
+              </a:rPr>
+              <a:t>Pathway Reconstruction: Autoencoders can capture the hierarchical relationships and interactions within metabolic networks. By training an autoencoder on metabolic pathway data, it can learn to reconstruct the pathways and identify the key reactions and metabolites involved. This can provide insights into the functional relationships between reactions, the flow of metabolites, and the overall structure of the metabolic network.</a:t>
+            </a:r>
+          </a:p>
+          <a:p>
+            <a:pPr algn="l">
+              <a:buFont typeface="+mj-lt"/>
+              <a:buAutoNum type="arabicPeriod"/>
+            </a:pPr>
+            <a:r>
+              <a:rPr lang="en-US" sz="1100" b="0" i="0" dirty="0">
+                <a:solidFill>
+                  <a:srgbClr val="374151"/>
+                </a:solidFill>
+                <a:effectLst/>
+                <a:latin typeface="+mj-lt"/>
+              </a:rPr>
+              <a:t>Discovery of Novel Enzymatic Reactions: Autoencoders can be used to predict potential enzymatic reactions and uncover novel interactions within metabolic networks. By training an autoencoder on a comprehensive set of known enzymatic reactions, it can learn the underlying patterns and relationships. The decoder part of the autoencoder can then generate predictions of new enzymatic reactions based on the learned representations. These predictions can guide experimental investigations and contribute to the expansion and refinement of existing metabolic networks.</a:t>
+            </a:r>
+          </a:p>
+          <a:p>
+            <a:pPr algn="l"/>
+            <a:r>
+              <a:rPr lang="en-US" sz="1100" b="0" i="0" dirty="0">
+                <a:solidFill>
+                  <a:srgbClr val="374151"/>
+                </a:solidFill>
+                <a:effectLst/>
+                <a:latin typeface="+mj-lt"/>
+              </a:rPr>
+              <a:t>In summary, autoencoders offer valuable tools for analyzing cell lifelines and metabolic networks by extracting meaningful features, reconstructing patterns, detecting anomalies, and facilitating the discovery of novel interactions and reactions. These insights can advance our understanding of biological systems, disease mechanisms, and potential drug targets.</a:t>
+            </a:r>
+          </a:p>
+          <a:p>
+            <a:endParaRPr lang="da-DK" sz="1100" dirty="0">
+              <a:latin typeface="+mj-lt"/>
+            </a:endParaRPr>
+          </a:p>
+        </p:txBody>
+      </p:sp>
+      <p:sp>
+        <p:nvSpPr>
+          <p:cNvPr id="4" name="Slide Number Placeholder 3">
+            <a:extLst>
+              <a:ext uri="{FF2B5EF4-FFF2-40B4-BE49-F238E27FC236}">
+                <a16:creationId xmlns:a16="http://schemas.microsoft.com/office/drawing/2014/main" id="{FB397322-7415-8304-26DF-8B8987B56633}"/>
+              </a:ext>
+            </a:extLst>
+          </p:cNvPr>
+          <p:cNvSpPr>
+            <a:spLocks noGrp="1"/>
+          </p:cNvSpPr>
+          <p:nvPr>
+            <p:ph type="sldNum" sz="quarter" idx="11"/>
+          </p:nvPr>
+        </p:nvSpPr>
+        <p:spPr/>
+        <p:txBody>
+          <a:bodyPr/>
+          <a:lstStyle/>
+          <a:p>
+            <a:fld id="{103EA872-A674-449B-A120-B97244F8E91D}" type="slidenum">
+              <a:rPr lang="en-GB" smtClean="0"/>
+              <a:pPr/>
+              <a:t>34</a:t>
+            </a:fld>
+            <a:endParaRPr lang="en-GB" dirty="0"/>
+          </a:p>
+        </p:txBody>
+      </p:sp>
+    </p:spTree>
+    <p:extLst>
+      <p:ext uri="{BB962C8B-B14F-4D97-AF65-F5344CB8AC3E}">
+        <p14:creationId xmlns:p14="http://schemas.microsoft.com/office/powerpoint/2010/main" val="3285401051"/>
+      </p:ext>
+    </p:extLst>
+  </p:cSld>
+  <p:clrMapOvr>
+    <a:masterClrMapping/>
+  </p:clrMapOvr>
+</p:sld>
+</file>
+
+<file path=ppt/slides/slide35.xml><?xml version="1.0" encoding="utf-8"?>
+<p:sld xmlns:a="http://schemas.openxmlformats.org/drawingml/2006/main" xmlns:r="http://schemas.openxmlformats.org/officeDocument/2006/relationships" xmlns:p="http://schemas.openxmlformats.org/presentationml/2006/main">
+  <p:cSld>
+    <p:spTree>
+      <p:nvGrpSpPr>
+        <p:cNvPr id="1" name=""/>
+        <p:cNvGrpSpPr/>
+        <p:nvPr/>
+      </p:nvGrpSpPr>
+      <p:grpSpPr>
+        <a:xfrm>
+          <a:off x="0" y="0"/>
+          <a:ext cx="0" cy="0"/>
+          <a:chOff x="0" y="0"/>
+          <a:chExt cx="0" cy="0"/>
+        </a:xfrm>
+      </p:grpSpPr>
+      <p:sp>
+        <p:nvSpPr>
+          <p:cNvPr id="2" name="Title 1">
+            <a:extLst>
+              <a:ext uri="{FF2B5EF4-FFF2-40B4-BE49-F238E27FC236}">
+                <a16:creationId xmlns:a16="http://schemas.microsoft.com/office/drawing/2014/main" id="{A53C08FB-0846-DDA6-B07A-5D1BECD3A1BE}"/>
+              </a:ext>
+            </a:extLst>
+          </p:cNvPr>
+          <p:cNvSpPr>
+            <a:spLocks noGrp="1"/>
+          </p:cNvSpPr>
+          <p:nvPr>
+            <p:ph type="title"/>
+          </p:nvPr>
+        </p:nvSpPr>
+        <p:spPr/>
+        <p:txBody>
+          <a:bodyPr/>
+          <a:lstStyle/>
+          <a:p>
+            <a:r>
+              <a:rPr lang="en-US" dirty="0"/>
+              <a:t>Notes</a:t>
+            </a:r>
+            <a:endParaRPr lang="da-DK" dirty="0"/>
+          </a:p>
+        </p:txBody>
+      </p:sp>
+      <p:sp>
+        <p:nvSpPr>
+          <p:cNvPr id="3" name="Content Placeholder 2">
+            <a:extLst>
+              <a:ext uri="{FF2B5EF4-FFF2-40B4-BE49-F238E27FC236}">
+                <a16:creationId xmlns:a16="http://schemas.microsoft.com/office/drawing/2014/main" id="{EF2C1B03-E041-86B0-950D-82FF37F6ACF2}"/>
+              </a:ext>
+            </a:extLst>
+          </p:cNvPr>
+          <p:cNvSpPr>
+            <a:spLocks noGrp="1"/>
+          </p:cNvSpPr>
+          <p:nvPr>
+            <p:ph idx="1"/>
+          </p:nvPr>
+        </p:nvSpPr>
+        <p:spPr/>
+        <p:txBody>
+          <a:bodyPr/>
+          <a:lstStyle/>
+          <a:p>
+            <a:pPr algn="l">
+              <a:buFont typeface="+mj-lt"/>
+              <a:buAutoNum type="arabicPeriod"/>
+            </a:pPr>
+            <a:r>
+              <a:rPr lang="en-US" b="0" i="0" dirty="0">
+                <a:solidFill>
+                  <a:srgbClr val="374151"/>
+                </a:solidFill>
+                <a:effectLst/>
+                <a:latin typeface="Söhne"/>
+              </a:rPr>
+              <a:t>Increase the number of hidden units in the encoder and decoder layers: This can provide more capacity for the model to capture the patterns and features in the data.</a:t>
+            </a:r>
+          </a:p>
+          <a:p>
+            <a:pPr algn="l">
+              <a:buFont typeface="+mj-lt"/>
+              <a:buAutoNum type="arabicPeriod"/>
+            </a:pPr>
+            <a:r>
+              <a:rPr lang="en-US" b="0" i="0" dirty="0">
+                <a:solidFill>
+                  <a:srgbClr val="374151"/>
+                </a:solidFill>
+                <a:effectLst/>
+                <a:latin typeface="Söhne"/>
+              </a:rPr>
+              <a:t>Add more layers to the encoder and decoder: Increasing the depth of the model can help it learn more complex representations.</a:t>
+            </a:r>
+          </a:p>
+          <a:p>
+            <a:pPr algn="l">
+              <a:buFont typeface="+mj-lt"/>
+              <a:buAutoNum type="arabicPeriod"/>
+            </a:pPr>
+            <a:r>
+              <a:rPr lang="en-US" b="0" i="0" dirty="0">
+                <a:solidFill>
+                  <a:srgbClr val="374151"/>
+                </a:solidFill>
+                <a:effectLst/>
+                <a:latin typeface="Söhne"/>
+              </a:rPr>
+              <a:t>Experiment with different activation functions: Try different activation functions such as '</a:t>
+            </a:r>
+            <a:r>
+              <a:rPr lang="en-US" b="0" i="0" dirty="0" err="1">
+                <a:solidFill>
+                  <a:srgbClr val="374151"/>
+                </a:solidFill>
+                <a:effectLst/>
+                <a:latin typeface="Söhne"/>
+              </a:rPr>
+              <a:t>relu</a:t>
+            </a:r>
+            <a:r>
+              <a:rPr lang="en-US" b="0" i="0" dirty="0">
+                <a:solidFill>
+                  <a:srgbClr val="374151"/>
+                </a:solidFill>
+                <a:effectLst/>
+                <a:latin typeface="Söhne"/>
+              </a:rPr>
+              <a:t>', 'tanh', or 'sigmoid' to see which works best for your data.</a:t>
+            </a:r>
+          </a:p>
+          <a:p>
+            <a:pPr algn="l">
+              <a:buFont typeface="+mj-lt"/>
+              <a:buAutoNum type="arabicPeriod"/>
+            </a:pPr>
+            <a:r>
+              <a:rPr lang="en-US" b="0" i="0" dirty="0">
+                <a:solidFill>
+                  <a:srgbClr val="374151"/>
+                </a:solidFill>
+                <a:effectLst/>
+                <a:latin typeface="Söhne"/>
+              </a:rPr>
+              <a:t>Increase the number of training epochs: Training the model for more epochs can allow it to converge to a better solution. However, be cautious not to overfit the data.</a:t>
+            </a:r>
+          </a:p>
+          <a:p>
+            <a:pPr algn="l">
+              <a:buFont typeface="+mj-lt"/>
+              <a:buAutoNum type="arabicPeriod"/>
+            </a:pPr>
+            <a:r>
+              <a:rPr lang="en-US" b="0" i="0" dirty="0">
+                <a:solidFill>
+                  <a:srgbClr val="374151"/>
+                </a:solidFill>
+                <a:effectLst/>
+                <a:latin typeface="Söhne"/>
+              </a:rPr>
+              <a:t>Adjust the learning rate: Experiment with different learning rates to find the optimal value for your model.</a:t>
+            </a:r>
+          </a:p>
+          <a:p>
+            <a:pPr algn="l">
+              <a:buFont typeface="+mj-lt"/>
+              <a:buAutoNum type="arabicPeriod"/>
+            </a:pPr>
+            <a:r>
+              <a:rPr lang="en-US" b="0" i="0" dirty="0">
+                <a:solidFill>
+                  <a:srgbClr val="374151"/>
+                </a:solidFill>
+                <a:effectLst/>
+                <a:latin typeface="Söhne"/>
+              </a:rPr>
+              <a:t>Normalize the input data: Normalizing the input data can help the model learn more effectively and improve reconstruction quality.</a:t>
+            </a:r>
+          </a:p>
+          <a:p>
+            <a:endParaRPr lang="da-DK" dirty="0"/>
+          </a:p>
+        </p:txBody>
+      </p:sp>
+      <p:sp>
+        <p:nvSpPr>
+          <p:cNvPr id="4" name="Slide Number Placeholder 3">
+            <a:extLst>
+              <a:ext uri="{FF2B5EF4-FFF2-40B4-BE49-F238E27FC236}">
+                <a16:creationId xmlns:a16="http://schemas.microsoft.com/office/drawing/2014/main" id="{7598AC90-03D6-112D-452A-AF392584D89C}"/>
+              </a:ext>
+            </a:extLst>
+          </p:cNvPr>
+          <p:cNvSpPr>
+            <a:spLocks noGrp="1"/>
+          </p:cNvSpPr>
+          <p:nvPr>
+            <p:ph type="sldNum" sz="quarter" idx="11"/>
+          </p:nvPr>
+        </p:nvSpPr>
+        <p:spPr/>
+        <p:txBody>
+          <a:bodyPr/>
+          <a:lstStyle/>
+          <a:p>
+            <a:fld id="{103EA872-A674-449B-A120-B97244F8E91D}" type="slidenum">
+              <a:rPr lang="en-GB" smtClean="0"/>
+              <a:pPr/>
+              <a:t>35</a:t>
+            </a:fld>
+            <a:endParaRPr lang="en-GB" dirty="0"/>
+          </a:p>
+        </p:txBody>
+      </p:sp>
+    </p:spTree>
+    <p:extLst>
+      <p:ext uri="{BB962C8B-B14F-4D97-AF65-F5344CB8AC3E}">
+        <p14:creationId xmlns:p14="http://schemas.microsoft.com/office/powerpoint/2010/main" val="3441938139"/>
       </p:ext>
     </p:extLst>
   </p:cSld>
@@ -15810,7 +16621,7 @@
 </file>
 
 <file path=customXml/item1.xml><?xml version="1.0" encoding="utf-8"?>
-<TemplafySlideTemplateConfiguration><![CDATA[{"elementsMetadata":[],"enableDocumentContentUpdater":true,"documentContentValidatorConfiguration":{"enableDocumentContentValidator":false,"documentContentValidatorVersion":0},"slideId":"636837486369128185","version":"1.2"}]]></TemplafySlideTemplateConfiguration>
+<TemplafySlideFormConfiguration><![CDATA[{"formFields":[],"formDataEntries":[]}]]></TemplafySlideFormConfiguration>
 </file>
 
 <file path=customXml/item10.xml><?xml version="1.0" encoding="utf-8"?>
@@ -15818,22 +16629,14 @@
 </file>
 
 <file path=customXml/item11.xml><?xml version="1.0" encoding="utf-8"?>
-<TemplafySlideFormConfiguration><![CDATA[{"formFields":[],"formDataEntries":[]}]]></TemplafySlideFormConfiguration>
+<TemplafySlideTemplateConfiguration><![CDATA[{"elementsMetadata":[],"enableDocumentContentUpdater":true,"documentContentValidatorConfiguration":{"enableDocumentContentValidator":false,"documentContentValidatorVersion":0},"slideId":"636837486369128185","version":"1.2"}]]></TemplafySlideTemplateConfiguration>
 </file>
 
 <file path=customXml/item12.xml><?xml version="1.0" encoding="utf-8"?>
-<TemplafySlideFormConfiguration><![CDATA[{"formFields":[],"formDataEntries":[]}]]></TemplafySlideFormConfiguration>
+<TemplafySlideTemplateConfiguration><![CDATA[{"elementsMetadata":[],"enableDocumentContentUpdater":true,"documentContentValidatorConfiguration":{"enableDocumentContentValidator":false,"documentContentValidatorVersion":0},"slideId":"636837486366003040","version":"1.2"}]]></TemplafySlideTemplateConfiguration>
 </file>
 
 <file path=customXml/item13.xml><?xml version="1.0" encoding="utf-8"?>
-<TemplafyTemplateConfiguration><![CDATA[{"elementsMetadata":[{"type":"shape","id":"2fce62a0-f28a-44e1-a519-0cbe37b25f7a","elementConfiguration":{"binding":"UserProfile.Offices.Workarea_{{DocumentLanguage}}","disableUpdates":false,"type":"text"}},{"type":"shape","id":"58465eeb-cfe0-4970-97ec-88179dc0a9c2","elementConfiguration":{"binding":"Form.Date","format":"{{DateFormats.GeneralDate}}","disableUpdates":false,"type":"date"}},{"type":"shape","id":"5020bdfb-1912-4d6d-a5c3-71b7da283692","elementConfiguration":{"binding":"Form.PresentationTitle","disableUpdates":false,"type":"text"}},{"type":"shape","id":"8d5b95d1-8a23-4044-9620-bf5e7305a170","elementConfiguration":{"binding":"UserProfile.Offices.Workarea_{{DocumentLanguage}}","disableUpdates":false,"type":"text"}},{"type":"shape","id":"79fbb3c3-dd89-47ef-91e9-e0bd2bb0942f","elementConfiguration":{"binding":"Form.Date","format":"{{DateFormats.GeneralDate}}","disableUpdates":false,"type":"date"}},{"type":"shape","id":"5e9447ba-0dff-46ec-ac33-540c046ca40a","elementConfiguration":{"binding":"Form.PresentationTitle","disableUpdates":false,"type":"text"}}],"transformationConfigurations":[{"language":"{{DocumentLanguage}}","disableUpdates":false,"type":"proofingLanguage"}],"enableDocumentContentUpdater":true,"templateName":"DTU Template 16_9 - Corporate red","templateDescription":"","version":"1.2"}]]></TemplafyTemplateConfiguration>
-</file>
-
-<file path=customXml/item14.xml><?xml version="1.0" encoding="utf-8"?>
-<TemplafySlideTemplateConfiguration><![CDATA[{"elementsMetadata":[],"enableDocumentContentUpdater":true,"documentContentValidatorConfiguration":{"enableDocumentContentValidator":false,"documentContentValidatorVersion":0},"slideId":"636837486369753289","version":"1.2"}]]></TemplafySlideTemplateConfiguration>
-</file>
-
-<file path=customXml/item15.xml><?xml version="1.0" encoding="utf-8"?>
 <?mso-contentType ?>
 <FormTemplates xmlns="http://schemas.microsoft.com/sharepoint/v3/contenttype/forms">
   <Display>DocumentLibraryForm</Display>
@@ -15842,19 +16645,67 @@
 </FormTemplates>
 </file>
 
+<file path=customXml/item14.xml><?xml version="1.0" encoding="utf-8"?>
+<TemplafyTemplateConfiguration><![CDATA[{"elementsMetadata":[{"type":"shape","id":"2fce62a0-f28a-44e1-a519-0cbe37b25f7a","elementConfiguration":{"binding":"UserProfile.Offices.Workarea_{{DocumentLanguage}}","disableUpdates":false,"type":"text"}},{"type":"shape","id":"58465eeb-cfe0-4970-97ec-88179dc0a9c2","elementConfiguration":{"binding":"Form.Date","format":"{{DateFormats.GeneralDate}}","disableUpdates":false,"type":"date"}},{"type":"shape","id":"5020bdfb-1912-4d6d-a5c3-71b7da283692","elementConfiguration":{"binding":"Form.PresentationTitle","disableUpdates":false,"type":"text"}},{"type":"shape","id":"8d5b95d1-8a23-4044-9620-bf5e7305a170","elementConfiguration":{"binding":"UserProfile.Offices.Workarea_{{DocumentLanguage}}","disableUpdates":false,"type":"text"}},{"type":"shape","id":"79fbb3c3-dd89-47ef-91e9-e0bd2bb0942f","elementConfiguration":{"binding":"Form.Date","format":"{{DateFormats.GeneralDate}}","disableUpdates":false,"type":"date"}},{"type":"shape","id":"5e9447ba-0dff-46ec-ac33-540c046ca40a","elementConfiguration":{"binding":"Form.PresentationTitle","disableUpdates":false,"type":"text"}}],"transformationConfigurations":[{"language":"{{DocumentLanguage}}","disableUpdates":false,"type":"proofingLanguage"}],"enableDocumentContentUpdater":true,"templateName":"DTU Template 16_9 - Corporate red","templateDescription":"","version":"1.2"}]]></TemplafyTemplateConfiguration>
+</file>
+
+<file path=customXml/item15.xml><?xml version="1.0" encoding="utf-8"?>
+<TemplafySlideFormConfiguration><![CDATA[{"formFields":[],"formDataEntries":[]}]]></TemplafySlideFormConfiguration>
+</file>
+
 <file path=customXml/item16.xml><?xml version="1.0" encoding="utf-8"?>
 <TemplafySlideTemplateConfiguration><![CDATA[{"elementsMetadata":[],"enableDocumentContentUpdater":true,"documentContentValidatorConfiguration":{"enableDocumentContentValidator":false,"documentContentValidatorVersion":0},"slideId":"636837486369128185","version":"1.2"}]]></TemplafySlideTemplateConfiguration>
 </file>
 
 <file path=customXml/item17.xml><?xml version="1.0" encoding="utf-8"?>
+<TemplafySlideTemplateConfiguration><![CDATA[{"elementsMetadata":[],"enableDocumentContentUpdater":true,"documentContentValidatorConfiguration":{"enableDocumentContentValidator":false,"documentContentValidatorVersion":0},"slideId":"636837486369128185","version":"1.2"}]]></TemplafySlideTemplateConfiguration>
+</file>
+
+<file path=customXml/item18.xml><?xml version="1.0" encoding="utf-8"?>
 <TemplafySlideFormConfiguration><![CDATA[{"formFields":[],"formDataEntries":[]}]]></TemplafySlideFormConfiguration>
 </file>
 
-<file path=customXml/item2.xml><?xml version="1.0" encoding="utf-8"?>
+<file path=customXml/item19.xml><?xml version="1.0" encoding="utf-8"?>
 <TemplafySlideTemplateConfiguration><![CDATA[{"elementsMetadata":[],"enableDocumentContentUpdater":true,"documentContentValidatorConfiguration":{"enableDocumentContentValidator":false,"documentContentValidatorVersion":0},"slideId":"636837486369128185","version":"1.2"}]]></TemplafySlideTemplateConfiguration>
 </file>
 
+<file path=customXml/item2.xml><?xml version="1.0" encoding="utf-8"?>
+<TemplafySlideFormConfiguration><![CDATA[{"formFields":[],"formDataEntries":[]}]]></TemplafySlideFormConfiguration>
+</file>
+
+<file path=customXml/item20.xml><?xml version="1.0" encoding="utf-8"?>
+<TemplafySlideFormConfiguration><![CDATA[{"formFields":[],"formDataEntries":[]}]]></TemplafySlideFormConfiguration>
+</file>
+
+<file path=customXml/item21.xml><?xml version="1.0" encoding="utf-8"?>
+<TemplafySlideTemplateConfiguration><![CDATA[{"elementsMetadata":[],"enableDocumentContentUpdater":true,"documentContentValidatorConfiguration":{"enableDocumentContentValidator":false,"documentContentValidatorVersion":0},"slideId":"636837486369753289","version":"1.2"}]]></TemplafySlideTemplateConfiguration>
+</file>
+
 <file path=customXml/item3.xml><?xml version="1.0" encoding="utf-8"?>
+<TemplafySlideFormConfiguration><![CDATA[{"formFields":[],"formDataEntries":[]}]]></TemplafySlideFormConfiguration>
+</file>
+
+<file path=customXml/item4.xml><?xml version="1.0" encoding="utf-8"?>
+<p:properties xmlns:p="http://schemas.microsoft.com/office/2006/metadata/properties" xmlns:xsi="http://www.w3.org/2001/XMLSchema-instance" xmlns:pc="http://schemas.microsoft.com/office/infopath/2007/PartnerControls">
+  <documentManagement>
+    <_activity xmlns="a474ea3f-da19-4978-b129-c19c0cdb3db7" xsi:nil="true"/>
+  </documentManagement>
+</p:properties>
+</file>
+
+<file path=customXml/item5.xml><?xml version="1.0" encoding="utf-8"?>
+<TemplafySlideTemplateConfiguration><![CDATA[{"elementsMetadata":[],"enableDocumentContentUpdater":true,"documentContentValidatorConfiguration":{"enableDocumentContentValidator":false,"documentContentValidatorVersion":0},"slideId":"636837486369128185","version":"1.2"}]]></TemplafySlideTemplateConfiguration>
+</file>
+
+<file path=customXml/item6.xml><?xml version="1.0" encoding="utf-8"?>
+<TemplafySlideTemplateConfiguration><![CDATA[{"elementsMetadata":[],"enableDocumentContentUpdater":true,"documentContentValidatorConfiguration":{"enableDocumentContentValidator":false,"documentContentValidatorVersion":0},"slideId":"636837486369753289","version":"1.2"}]]></TemplafySlideTemplateConfiguration>
+</file>
+
+<file path=customXml/item7.xml><?xml version="1.0" encoding="utf-8"?>
+<TemplafyFormConfiguration><![CDATA[{"formFields":[{"required":false,"type":"datePicker","name":"Date","label":"Date","helpTexts":{"prefix":"","postfix":""},"spacing":{},"fullyQualifiedName":"Date"},{"required":false,"placeholder":"","lines":0,"type":"textBox","name":"PresentationTitle","label":"Presentation title","helpTexts":{"prefix":"","postfix":""},"spacing":{},"fullyQualifiedName":"PresentationTitle"}],"formDataEntries":[{"name":"Date","value":"4Xm7d242HGo446IH5nRjQA=="},{"name":"PresentationTitle","value":"ZR/I84ubq+6CkRKNk7nn9w=="}]}]]></TemplafyFormConfiguration>
+</file>
+
+<file path=customXml/item8.xml><?xml version="1.0" encoding="utf-8"?>
 <ct:contentTypeSchema xmlns:ct="http://schemas.microsoft.com/office/2006/metadata/contentType" xmlns:ma="http://schemas.microsoft.com/office/2006/metadata/properties/metaAttributes" ct:_="" ma:_="" ma:contentTypeName="Dokument" ma:contentTypeID="0x01010064A971A7B4EF0844A363E03BDAF31A83" ma:contentTypeVersion="13" ma:contentTypeDescription="Opret et nyt dokument." ma:contentTypeScope="" ma:versionID="368ecb79621beb6c191c90a96be15b34">
   <xsd:schema xmlns:xsd="http://www.w3.org/2001/XMLSchema" xmlns:xs="http://www.w3.org/2001/XMLSchema" xmlns:p="http://schemas.microsoft.com/office/2006/metadata/properties" xmlns:ns3="a474ea3f-da19-4978-b129-c19c0cdb3db7" xmlns:ns4="c1157c6f-c381-408b-9e9e-d022236b16f4" targetNamespace="http://schemas.microsoft.com/office/2006/metadata/properties" ma:root="true" ma:fieldsID="d3165400d772c5f3511f5ff6ec469c36" ns3:_="" ns4:_="">
     <xsd:import namespace="a474ea3f-da19-4978-b129-c19c0cdb3db7"/>
@@ -16075,71 +16926,35 @@
 </ct:contentTypeSchema>
 </file>
 
-<file path=customXml/item4.xml><?xml version="1.0" encoding="utf-8"?>
-<p:properties xmlns:p="http://schemas.microsoft.com/office/2006/metadata/properties" xmlns:xsi="http://www.w3.org/2001/XMLSchema-instance" xmlns:pc="http://schemas.microsoft.com/office/infopath/2007/PartnerControls">
-  <documentManagement>
-    <_activity xmlns="a474ea3f-da19-4978-b129-c19c0cdb3db7" xsi:nil="true"/>
-  </documentManagement>
-</p:properties>
-</file>
-
-<file path=customXml/item5.xml><?xml version="1.0" encoding="utf-8"?>
+<file path=customXml/item9.xml><?xml version="1.0" encoding="utf-8"?>
 <TemplafySlideFormConfiguration><![CDATA[{"formFields":[],"formDataEntries":[]}]]></TemplafySlideFormConfiguration>
 </file>
 
-<file path=customXml/item6.xml><?xml version="1.0" encoding="utf-8"?>
-<TemplafySlideTemplateConfiguration><![CDATA[{"elementsMetadata":[],"enableDocumentContentUpdater":true,"documentContentValidatorConfiguration":{"enableDocumentContentValidator":false,"documentContentValidatorVersion":0},"slideId":"636837486366003040","version":"1.2"}]]></TemplafySlideTemplateConfiguration>
+<file path=customXml/itemProps1.xml><?xml version="1.0" encoding="utf-8"?>
+<ds:datastoreItem xmlns:ds="http://schemas.openxmlformats.org/officeDocument/2006/customXml" ds:itemID="{8660AB89-308F-4A34-B01B-CC1A9333F1B1}">
+  <ds:schemaRefs/>
+</ds:datastoreItem>
 </file>
 
-<file path=customXml/item7.xml><?xml version="1.0" encoding="utf-8"?>
-<TemplafySlideFormConfiguration><![CDATA[{"formFields":[],"formDataEntries":[]}]]></TemplafySlideFormConfiguration>
+<file path=customXml/itemProps10.xml><?xml version="1.0" encoding="utf-8"?>
+<ds:datastoreItem xmlns:ds="http://schemas.openxmlformats.org/officeDocument/2006/customXml" ds:itemID="{586CB63B-5DC3-4AE3-A336-DC54F3E0DFEF}">
+  <ds:schemaRefs/>
+</ds:datastoreItem>
 </file>
 
-<file path=customXml/item8.xml><?xml version="1.0" encoding="utf-8"?>
-<TemplafyFormConfiguration><![CDATA[{"formFields":[{"required":false,"type":"datePicker","name":"Date","label":"Date","helpTexts":{"prefix":"","postfix":""},"spacing":{},"fullyQualifiedName":"Date"},{"required":false,"placeholder":"","lines":0,"type":"textBox","name":"PresentationTitle","label":"Presentation title","helpTexts":{"prefix":"","postfix":""},"spacing":{},"fullyQualifiedName":"PresentationTitle"}],"formDataEntries":[{"name":"Date","value":"4Xm7d242HGo446IH5nRjQA=="},{"name":"PresentationTitle","value":"ZR/I84ubq+6CkRKNk7nn9w=="}]}]]></TemplafyFormConfiguration>
-</file>
-
-<file path=customXml/item9.xml><?xml version="1.0" encoding="utf-8"?>
-<TemplafySlideTemplateConfiguration><![CDATA[{"elementsMetadata":[],"enableDocumentContentUpdater":true,"documentContentValidatorConfiguration":{"enableDocumentContentValidator":false,"documentContentValidatorVersion":0},"slideId":"636837486369128185","version":"1.2"}]]></TemplafySlideTemplateConfiguration>
-</file>
-
-<file path=customXml/itemProps1.xml><?xml version="1.0" encoding="utf-8"?>
+<file path=customXml/itemProps11.xml><?xml version="1.0" encoding="utf-8"?>
 <ds:datastoreItem xmlns:ds="http://schemas.openxmlformats.org/officeDocument/2006/customXml" ds:itemID="{11FAAC39-0A3A-4CC2-A9C1-60940B78AE17}">
   <ds:schemaRefs/>
 </ds:datastoreItem>
 </file>
 
-<file path=customXml/itemProps10.xml><?xml version="1.0" encoding="utf-8"?>
-<ds:datastoreItem xmlns:ds="http://schemas.openxmlformats.org/officeDocument/2006/customXml" ds:itemID="{F4C08C7F-F953-44DE-ACDE-930692BDDB0F}">
-  <ds:schemaRefs/>
-</ds:datastoreItem>
-</file>
-
-<file path=customXml/itemProps11.xml><?xml version="1.0" encoding="utf-8"?>
-<ds:datastoreItem xmlns:ds="http://schemas.openxmlformats.org/officeDocument/2006/customXml" ds:itemID="{8660AB89-308F-4A34-B01B-CC1A9333F1B1}">
-  <ds:schemaRefs/>
-</ds:datastoreItem>
-</file>
-
 <file path=customXml/itemProps12.xml><?xml version="1.0" encoding="utf-8"?>
-<ds:datastoreItem xmlns:ds="http://schemas.openxmlformats.org/officeDocument/2006/customXml" ds:itemID="{56C8BFB2-A911-4310-9D4A-421D773FAFA6}">
+<ds:datastoreItem xmlns:ds="http://schemas.openxmlformats.org/officeDocument/2006/customXml" ds:itemID="{E5957E33-0059-46CE-AE7B-582F67E40B53}">
   <ds:schemaRefs/>
 </ds:datastoreItem>
 </file>
 
 <file path=customXml/itemProps13.xml><?xml version="1.0" encoding="utf-8"?>
-<ds:datastoreItem xmlns:ds="http://schemas.openxmlformats.org/officeDocument/2006/customXml" ds:itemID="{1334258C-C3E7-4029-A615-C886A240FB15}">
-  <ds:schemaRefs/>
-</ds:datastoreItem>
-</file>
-
-<file path=customXml/itemProps14.xml><?xml version="1.0" encoding="utf-8"?>
-<ds:datastoreItem xmlns:ds="http://schemas.openxmlformats.org/officeDocument/2006/customXml" ds:itemID="{02E7CCCE-613B-4CED-B813-E473EA1E01B2}">
-  <ds:schemaRefs/>
-</ds:datastoreItem>
-</file>
-
-<file path=customXml/itemProps15.xml><?xml version="1.0" encoding="utf-8"?>
 <ds:datastoreItem xmlns:ds="http://schemas.openxmlformats.org/officeDocument/2006/customXml" ds:itemID="{07E7C233-EFE0-424C-BC60-74F1F060E8E9}">
   <ds:schemaRefs>
     <ds:schemaRef ds:uri="http://schemas.microsoft.com/sharepoint/v3/contenttype/forms"/>
@@ -16147,40 +16962,63 @@
 </ds:datastoreItem>
 </file>
 
+<file path=customXml/itemProps14.xml><?xml version="1.0" encoding="utf-8"?>
+<ds:datastoreItem xmlns:ds="http://schemas.openxmlformats.org/officeDocument/2006/customXml" ds:itemID="{1334258C-C3E7-4029-A615-C886A240FB15}">
+  <ds:schemaRefs/>
+</ds:datastoreItem>
+</file>
+
+<file path=customXml/itemProps15.xml><?xml version="1.0" encoding="utf-8"?>
+<ds:datastoreItem xmlns:ds="http://schemas.openxmlformats.org/officeDocument/2006/customXml" ds:itemID="{A092F9D7-A29F-41D7-8B88-96E18CAF830E}">
+  <ds:schemaRefs/>
+</ds:datastoreItem>
+</file>
+
 <file path=customXml/itemProps16.xml><?xml version="1.0" encoding="utf-8"?>
+<ds:datastoreItem xmlns:ds="http://schemas.openxmlformats.org/officeDocument/2006/customXml" ds:itemID="{99A8A5E8-B632-4217-82CB-76FE390F5BEC}">
+  <ds:schemaRefs/>
+</ds:datastoreItem>
+</file>
+
+<file path=customXml/itemProps17.xml><?xml version="1.0" encoding="utf-8"?>
 <ds:datastoreItem xmlns:ds="http://schemas.openxmlformats.org/officeDocument/2006/customXml" ds:itemID="{E8497AF2-D3CC-484F-8958-D83710F84D34}">
   <ds:schemaRefs/>
 </ds:datastoreItem>
 </file>
 
-<file path=customXml/itemProps17.xml><?xml version="1.0" encoding="utf-8"?>
-<ds:datastoreItem xmlns:ds="http://schemas.openxmlformats.org/officeDocument/2006/customXml" ds:itemID="{586CB63B-5DC3-4AE3-A336-DC54F3E0DFEF}">
+<file path=customXml/itemProps18.xml><?xml version="1.0" encoding="utf-8"?>
+<ds:datastoreItem xmlns:ds="http://schemas.openxmlformats.org/officeDocument/2006/customXml" ds:itemID="{B513C2C7-63CE-445A-BF41-AD73F1D56AE9}">
+  <ds:schemaRefs/>
+</ds:datastoreItem>
+</file>
+
+<file path=customXml/itemProps19.xml><?xml version="1.0" encoding="utf-8"?>
+<ds:datastoreItem xmlns:ds="http://schemas.openxmlformats.org/officeDocument/2006/customXml" ds:itemID="{4A0EFB85-E73F-4350-94CE-FE07072F1A1D}">
   <ds:schemaRefs/>
 </ds:datastoreItem>
 </file>
 
 <file path=customXml/itemProps2.xml><?xml version="1.0" encoding="utf-8"?>
-<ds:datastoreItem xmlns:ds="http://schemas.openxmlformats.org/officeDocument/2006/customXml" ds:itemID="{99A8A5E8-B632-4217-82CB-76FE390F5BEC}">
+<ds:datastoreItem xmlns:ds="http://schemas.openxmlformats.org/officeDocument/2006/customXml" ds:itemID="{CEE82BD2-02AE-48C0-B241-9719E9F2F706}">
+  <ds:schemaRefs/>
+</ds:datastoreItem>
+</file>
+
+<file path=customXml/itemProps20.xml><?xml version="1.0" encoding="utf-8"?>
+<ds:datastoreItem xmlns:ds="http://schemas.openxmlformats.org/officeDocument/2006/customXml" ds:itemID="{4F0DA6B6-AF41-495D-B7B0-D586EA7DB8CE}">
+  <ds:schemaRefs/>
+</ds:datastoreItem>
+</file>
+
+<file path=customXml/itemProps21.xml><?xml version="1.0" encoding="utf-8"?>
+<ds:datastoreItem xmlns:ds="http://schemas.openxmlformats.org/officeDocument/2006/customXml" ds:itemID="{D0094D9D-9AD3-4087-A23E-DCC09869798A}">
   <ds:schemaRefs/>
 </ds:datastoreItem>
 </file>
 
 <file path=customXml/itemProps3.xml><?xml version="1.0" encoding="utf-8"?>
-<ds:datastoreItem xmlns:ds="http://schemas.openxmlformats.org/officeDocument/2006/customXml" ds:itemID="{7440E428-F9FB-4140-8430-537C82AFACDA}">
-  <ds:schemaRefs>
-    <ds:schemaRef ds:uri="http://schemas.microsoft.com/office/2006/metadata/contentType"/>
-    <ds:schemaRef ds:uri="http://schemas.microsoft.com/office/2006/metadata/properties/metaAttributes"/>
-    <ds:schemaRef ds:uri="http://www.w3.org/2001/XMLSchema"/>
-    <ds:schemaRef ds:uri="http://schemas.microsoft.com/office/2006/metadata/properties"/>
-    <ds:schemaRef ds:uri="a474ea3f-da19-4978-b129-c19c0cdb3db7"/>
-    <ds:schemaRef ds:uri="c1157c6f-c381-408b-9e9e-d022236b16f4"/>
-    <ds:schemaRef ds:uri="http://schemas.microsoft.com/office/2006/documentManagement/types"/>
-    <ds:schemaRef ds:uri="http://schemas.microsoft.com/office/infopath/2007/PartnerControls"/>
-    <ds:schemaRef ds:uri="http://schemas.openxmlformats.org/package/2006/metadata/core-properties"/>
-    <ds:schemaRef ds:uri="http://purl.org/dc/elements/1.1/"/>
-    <ds:schemaRef ds:uri="http://purl.org/dc/terms/"/>
-    <ds:schemaRef ds:uri="http://schemas.microsoft.com/internal/obd"/>
-  </ds:schemaRefs>
+<ds:datastoreItem xmlns:ds="http://schemas.openxmlformats.org/officeDocument/2006/customXml" ds:itemID="{F4C08C7F-F953-44DE-ACDE-930692BDDB0F}">
+  <ds:schemaRefs/>
 </ds:datastoreItem>
 </file>
 
@@ -16202,31 +17040,44 @@
 </file>
 
 <file path=customXml/itemProps5.xml><?xml version="1.0" encoding="utf-8"?>
-<ds:datastoreItem xmlns:ds="http://schemas.openxmlformats.org/officeDocument/2006/customXml" ds:itemID="{CEE82BD2-02AE-48C0-B241-9719E9F2F706}">
+<ds:datastoreItem xmlns:ds="http://schemas.openxmlformats.org/officeDocument/2006/customXml" ds:itemID="{81E17DA4-C627-42DE-A231-F93020487DAF}">
   <ds:schemaRefs/>
 </ds:datastoreItem>
 </file>
 
 <file path=customXml/itemProps6.xml><?xml version="1.0" encoding="utf-8"?>
-<ds:datastoreItem xmlns:ds="http://schemas.openxmlformats.org/officeDocument/2006/customXml" ds:itemID="{E5957E33-0059-46CE-AE7B-582F67E40B53}">
+<ds:datastoreItem xmlns:ds="http://schemas.openxmlformats.org/officeDocument/2006/customXml" ds:itemID="{02E7CCCE-613B-4CED-B813-E473EA1E01B2}">
   <ds:schemaRefs/>
 </ds:datastoreItem>
 </file>
 
 <file path=customXml/itemProps7.xml><?xml version="1.0" encoding="utf-8"?>
-<ds:datastoreItem xmlns:ds="http://schemas.openxmlformats.org/officeDocument/2006/customXml" ds:itemID="{A092F9D7-A29F-41D7-8B88-96E18CAF830E}">
+<ds:datastoreItem xmlns:ds="http://schemas.openxmlformats.org/officeDocument/2006/customXml" ds:itemID="{05DC2B94-7C1B-4C14-83B0-9CD2A82C27E0}">
   <ds:schemaRefs/>
 </ds:datastoreItem>
 </file>
 
 <file path=customXml/itemProps8.xml><?xml version="1.0" encoding="utf-8"?>
-<ds:datastoreItem xmlns:ds="http://schemas.openxmlformats.org/officeDocument/2006/customXml" ds:itemID="{05DC2B94-7C1B-4C14-83B0-9CD2A82C27E0}">
-  <ds:schemaRefs/>
+<ds:datastoreItem xmlns:ds="http://schemas.openxmlformats.org/officeDocument/2006/customXml" ds:itemID="{7440E428-F9FB-4140-8430-537C82AFACDA}">
+  <ds:schemaRefs>
+    <ds:schemaRef ds:uri="http://schemas.microsoft.com/office/2006/metadata/contentType"/>
+    <ds:schemaRef ds:uri="http://schemas.microsoft.com/office/2006/metadata/properties/metaAttributes"/>
+    <ds:schemaRef ds:uri="http://www.w3.org/2001/XMLSchema"/>
+    <ds:schemaRef ds:uri="http://schemas.microsoft.com/office/2006/metadata/properties"/>
+    <ds:schemaRef ds:uri="a474ea3f-da19-4978-b129-c19c0cdb3db7"/>
+    <ds:schemaRef ds:uri="c1157c6f-c381-408b-9e9e-d022236b16f4"/>
+    <ds:schemaRef ds:uri="http://schemas.microsoft.com/office/2006/documentManagement/types"/>
+    <ds:schemaRef ds:uri="http://schemas.microsoft.com/office/infopath/2007/PartnerControls"/>
+    <ds:schemaRef ds:uri="http://schemas.openxmlformats.org/package/2006/metadata/core-properties"/>
+    <ds:schemaRef ds:uri="http://purl.org/dc/elements/1.1/"/>
+    <ds:schemaRef ds:uri="http://purl.org/dc/terms/"/>
+    <ds:schemaRef ds:uri="http://schemas.microsoft.com/internal/obd"/>
+  </ds:schemaRefs>
 </ds:datastoreItem>
 </file>
 
 <file path=customXml/itemProps9.xml><?xml version="1.0" encoding="utf-8"?>
-<ds:datastoreItem xmlns:ds="http://schemas.openxmlformats.org/officeDocument/2006/customXml" ds:itemID="{81E17DA4-C627-42DE-A231-F93020487DAF}">
+<ds:datastoreItem xmlns:ds="http://schemas.openxmlformats.org/officeDocument/2006/customXml" ds:itemID="{56C8BFB2-A911-4310-9D4A-421D773FAFA6}">
   <ds:schemaRefs/>
 </ds:datastoreItem>
 </file>
</xml_diff>